<commit_message>
Fixed a slide deck in 105
</commit_message>
<xml_diff>
--- a/src/teaching/2021-2022/105-data-viz/slides/Preparing Data in Tableau.pptx
+++ b/src/teaching/2021-2022/105-data-viz/slides/Preparing Data in Tableau.pptx
@@ -6,39 +6,43 @@
     <p:sldMasterId id="2147484153" r:id="rId2"/>
   </p:sldMasterIdLst>
   <p:notesMasterIdLst>
-    <p:notesMasterId r:id="rId25"/>
+    <p:notesMasterId r:id="rId29"/>
   </p:notesMasterIdLst>
   <p:handoutMasterIdLst>
-    <p:handoutMasterId r:id="rId26"/>
+    <p:handoutMasterId r:id="rId30"/>
   </p:handoutMasterIdLst>
   <p:sldIdLst>
     <p:sldId id="256" r:id="rId3"/>
-    <p:sldId id="539" r:id="rId4"/>
-    <p:sldId id="536" r:id="rId5"/>
-    <p:sldId id="547" r:id="rId6"/>
-    <p:sldId id="564" r:id="rId7"/>
-    <p:sldId id="528" r:id="rId8"/>
-    <p:sldId id="546" r:id="rId9"/>
-    <p:sldId id="565" r:id="rId10"/>
-    <p:sldId id="538" r:id="rId11"/>
-    <p:sldId id="566" r:id="rId12"/>
-    <p:sldId id="568" r:id="rId13"/>
-    <p:sldId id="567" r:id="rId14"/>
-    <p:sldId id="533" r:id="rId15"/>
-    <p:sldId id="556" r:id="rId16"/>
-    <p:sldId id="569" r:id="rId17"/>
-    <p:sldId id="570" r:id="rId18"/>
-    <p:sldId id="557" r:id="rId19"/>
-    <p:sldId id="534" r:id="rId20"/>
-    <p:sldId id="542" r:id="rId21"/>
-    <p:sldId id="571" r:id="rId22"/>
-    <p:sldId id="558" r:id="rId23"/>
-    <p:sldId id="426" r:id="rId24"/>
+    <p:sldId id="572" r:id="rId4"/>
+    <p:sldId id="573" r:id="rId5"/>
+    <p:sldId id="574" r:id="rId6"/>
+    <p:sldId id="575" r:id="rId7"/>
+    <p:sldId id="539" r:id="rId8"/>
+    <p:sldId id="536" r:id="rId9"/>
+    <p:sldId id="547" r:id="rId10"/>
+    <p:sldId id="564" r:id="rId11"/>
+    <p:sldId id="528" r:id="rId12"/>
+    <p:sldId id="546" r:id="rId13"/>
+    <p:sldId id="565" r:id="rId14"/>
+    <p:sldId id="538" r:id="rId15"/>
+    <p:sldId id="566" r:id="rId16"/>
+    <p:sldId id="568" r:id="rId17"/>
+    <p:sldId id="567" r:id="rId18"/>
+    <p:sldId id="533" r:id="rId19"/>
+    <p:sldId id="556" r:id="rId20"/>
+    <p:sldId id="569" r:id="rId21"/>
+    <p:sldId id="570" r:id="rId22"/>
+    <p:sldId id="557" r:id="rId23"/>
+    <p:sldId id="534" r:id="rId24"/>
+    <p:sldId id="542" r:id="rId25"/>
+    <p:sldId id="571" r:id="rId26"/>
+    <p:sldId id="558" r:id="rId27"/>
+    <p:sldId id="426" r:id="rId28"/>
   </p:sldIdLst>
   <p:sldSz cx="14630400" cy="8229600"/>
   <p:notesSz cx="6858000" cy="9144000"/>
   <p:custDataLst>
-    <p:tags r:id="rId27"/>
+    <p:tags r:id="rId31"/>
   </p:custDataLst>
   <p:defaultTextStyle>
     <a:defPPr>
@@ -934,14 +938,14 @@
           </a:ln>
           <a:extLst>
             <a:ext uri="{909E8E84-426E-40dd-AFC4-6F175D3DCCD1}">
-              <a14:hiddenFill xmlns:a14="http://schemas.microsoft.com/office/drawing/2010/main" xmlns="">
+              <a14:hiddenFill xmlns="" xmlns:a14="http://schemas.microsoft.com/office/drawing/2010/main">
                 <a:solidFill>
                   <a:srgbClr val="FFFFFF"/>
                 </a:solidFill>
               </a14:hiddenFill>
             </a:ext>
             <a:ext uri="{FAA26D3D-D897-4be2-8F04-BA451C77F1D7}">
-              <ma14:placeholderFlag xmlns:ma14="http://schemas.microsoft.com/office/mac/drawingml/2011/main" xmlns="" val="1"/>
+              <ma14:placeholderFlag xmlns="" xmlns:ma14="http://schemas.microsoft.com/office/mac/drawingml/2011/main" val="1"/>
             </a:ext>
           </a:extLst>
         </p:spPr>
@@ -960,14 +964,14 @@
           <a:noFill/>
           <a:extLst>
             <a:ext uri="{909E8E84-426E-40dd-AFC4-6F175D3DCCD1}">
-              <a14:hiddenFill xmlns:a14="http://schemas.microsoft.com/office/drawing/2010/main" xmlns="">
+              <a14:hiddenFill xmlns="" xmlns:a14="http://schemas.microsoft.com/office/drawing/2010/main">
                 <a:solidFill>
                   <a:srgbClr val="FFFFFF"/>
                 </a:solidFill>
               </a14:hiddenFill>
             </a:ext>
             <a:ext uri="{91240B29-F687-4f45-9708-019B960494DF}">
-              <a14:hiddenLine xmlns:a14="http://schemas.microsoft.com/office/drawing/2010/main" xmlns="" w="9525">
+              <a14:hiddenLine xmlns="" xmlns:a14="http://schemas.microsoft.com/office/drawing/2010/main" w="9525">
                 <a:solidFill>
                   <a:srgbClr val="000000"/>
                 </a:solidFill>
@@ -1407,14 +1411,14 @@
           </a:ln>
           <a:extLst>
             <a:ext uri="{909E8E84-426E-40dd-AFC4-6F175D3DCCD1}">
-              <a14:hiddenFill xmlns:a14="http://schemas.microsoft.com/office/drawing/2010/main" xmlns="">
+              <a14:hiddenFill xmlns="" xmlns:a14="http://schemas.microsoft.com/office/drawing/2010/main">
                 <a:solidFill>
                   <a:srgbClr val="FFFFFF"/>
                 </a:solidFill>
               </a14:hiddenFill>
             </a:ext>
             <a:ext uri="{FAA26D3D-D897-4be2-8F04-BA451C77F1D7}">
-              <ma14:placeholderFlag xmlns:ma14="http://schemas.microsoft.com/office/mac/drawingml/2011/main" xmlns="" val="1"/>
+              <ma14:placeholderFlag xmlns="" xmlns:ma14="http://schemas.microsoft.com/office/mac/drawingml/2011/main" val="1"/>
             </a:ext>
           </a:extLst>
         </p:spPr>
@@ -1433,14 +1437,14 @@
           <a:noFill/>
           <a:extLst>
             <a:ext uri="{909E8E84-426E-40dd-AFC4-6F175D3DCCD1}">
-              <a14:hiddenFill xmlns:a14="http://schemas.microsoft.com/office/drawing/2010/main" xmlns="">
+              <a14:hiddenFill xmlns="" xmlns:a14="http://schemas.microsoft.com/office/drawing/2010/main">
                 <a:solidFill>
                   <a:srgbClr val="FFFFFF"/>
                 </a:solidFill>
               </a14:hiddenFill>
             </a:ext>
             <a:ext uri="{91240B29-F687-4f45-9708-019B960494DF}">
-              <a14:hiddenLine xmlns:a14="http://schemas.microsoft.com/office/drawing/2010/main" xmlns="" w="9525">
+              <a14:hiddenLine xmlns="" xmlns:a14="http://schemas.microsoft.com/office/drawing/2010/main" w="9525">
                 <a:solidFill>
                   <a:srgbClr val="000000"/>
                 </a:solidFill>
@@ -1525,14 +1529,14 @@
           </a:ln>
           <a:extLst>
             <a:ext uri="{909E8E84-426E-40dd-AFC4-6F175D3DCCD1}">
-              <a14:hiddenFill xmlns:a14="http://schemas.microsoft.com/office/drawing/2010/main" xmlns="">
+              <a14:hiddenFill xmlns="" xmlns:a14="http://schemas.microsoft.com/office/drawing/2010/main">
                 <a:solidFill>
                   <a:srgbClr val="FFFFFF"/>
                 </a:solidFill>
               </a14:hiddenFill>
             </a:ext>
             <a:ext uri="{FAA26D3D-D897-4be2-8F04-BA451C77F1D7}">
-              <ma14:placeholderFlag xmlns:ma14="http://schemas.microsoft.com/office/mac/drawingml/2011/main" xmlns="" val="1"/>
+              <ma14:placeholderFlag xmlns="" xmlns:ma14="http://schemas.microsoft.com/office/mac/drawingml/2011/main" val="1"/>
             </a:ext>
           </a:extLst>
         </p:spPr>
@@ -1551,14 +1555,14 @@
           <a:noFill/>
           <a:extLst>
             <a:ext uri="{909E8E84-426E-40dd-AFC4-6F175D3DCCD1}">
-              <a14:hiddenFill xmlns:a14="http://schemas.microsoft.com/office/drawing/2010/main" xmlns="">
+              <a14:hiddenFill xmlns="" xmlns:a14="http://schemas.microsoft.com/office/drawing/2010/main">
                 <a:solidFill>
                   <a:srgbClr val="FFFFFF"/>
                 </a:solidFill>
               </a14:hiddenFill>
             </a:ext>
             <a:ext uri="{91240B29-F687-4f45-9708-019B960494DF}">
-              <a14:hiddenLine xmlns:a14="http://schemas.microsoft.com/office/drawing/2010/main" xmlns="" w="9525">
+              <a14:hiddenLine xmlns="" xmlns:a14="http://schemas.microsoft.com/office/drawing/2010/main" w="9525">
                 <a:solidFill>
                   <a:srgbClr val="000000"/>
                 </a:solidFill>
@@ -1955,14 +1959,14 @@
           </a:ln>
           <a:extLst>
             <a:ext uri="{909E8E84-426E-40dd-AFC4-6F175D3DCCD1}">
-              <a14:hiddenFill xmlns:a14="http://schemas.microsoft.com/office/drawing/2010/main" xmlns="">
+              <a14:hiddenFill xmlns="" xmlns:a14="http://schemas.microsoft.com/office/drawing/2010/main">
                 <a:solidFill>
                   <a:srgbClr val="FFFFFF"/>
                 </a:solidFill>
               </a14:hiddenFill>
             </a:ext>
             <a:ext uri="{FAA26D3D-D897-4be2-8F04-BA451C77F1D7}">
-              <ma14:placeholderFlag xmlns:ma14="http://schemas.microsoft.com/office/mac/drawingml/2011/main" xmlns="" val="1"/>
+              <ma14:placeholderFlag xmlns="" xmlns:ma14="http://schemas.microsoft.com/office/mac/drawingml/2011/main" val="1"/>
             </a:ext>
           </a:extLst>
         </p:spPr>
@@ -1981,14 +1985,14 @@
           <a:noFill/>
           <a:extLst>
             <a:ext uri="{909E8E84-426E-40dd-AFC4-6F175D3DCCD1}">
-              <a14:hiddenFill xmlns:a14="http://schemas.microsoft.com/office/drawing/2010/main" xmlns="">
+              <a14:hiddenFill xmlns="" xmlns:a14="http://schemas.microsoft.com/office/drawing/2010/main">
                 <a:solidFill>
                   <a:srgbClr val="FFFFFF"/>
                 </a:solidFill>
               </a14:hiddenFill>
             </a:ext>
             <a:ext uri="{91240B29-F687-4f45-9708-019B960494DF}">
-              <a14:hiddenLine xmlns:a14="http://schemas.microsoft.com/office/drawing/2010/main" xmlns="" w="9525">
+              <a14:hiddenLine xmlns="" xmlns:a14="http://schemas.microsoft.com/office/drawing/2010/main" w="9525">
                 <a:solidFill>
                   <a:srgbClr val="000000"/>
                 </a:solidFill>
@@ -2073,14 +2077,14 @@
           </a:ln>
           <a:extLst>
             <a:ext uri="{909E8E84-426E-40dd-AFC4-6F175D3DCCD1}">
-              <a14:hiddenFill xmlns:a14="http://schemas.microsoft.com/office/drawing/2010/main" xmlns="">
+              <a14:hiddenFill xmlns="" xmlns:a14="http://schemas.microsoft.com/office/drawing/2010/main">
                 <a:solidFill>
                   <a:srgbClr val="FFFFFF"/>
                 </a:solidFill>
               </a14:hiddenFill>
             </a:ext>
             <a:ext uri="{FAA26D3D-D897-4be2-8F04-BA451C77F1D7}">
-              <ma14:placeholderFlag xmlns:ma14="http://schemas.microsoft.com/office/mac/drawingml/2011/main" xmlns="" val="1"/>
+              <ma14:placeholderFlag xmlns="" xmlns:ma14="http://schemas.microsoft.com/office/mac/drawingml/2011/main" val="1"/>
             </a:ext>
           </a:extLst>
         </p:spPr>
@@ -2099,14 +2103,14 @@
           <a:noFill/>
           <a:extLst>
             <a:ext uri="{909E8E84-426E-40dd-AFC4-6F175D3DCCD1}">
-              <a14:hiddenFill xmlns:a14="http://schemas.microsoft.com/office/drawing/2010/main" xmlns="">
+              <a14:hiddenFill xmlns="" xmlns:a14="http://schemas.microsoft.com/office/drawing/2010/main">
                 <a:solidFill>
                   <a:srgbClr val="FFFFFF"/>
                 </a:solidFill>
               </a14:hiddenFill>
             </a:ext>
             <a:ext uri="{91240B29-F687-4f45-9708-019B960494DF}">
-              <a14:hiddenLine xmlns:a14="http://schemas.microsoft.com/office/drawing/2010/main" xmlns="" w="9525">
+              <a14:hiddenLine xmlns="" xmlns:a14="http://schemas.microsoft.com/office/drawing/2010/main" w="9525">
                 <a:solidFill>
                   <a:srgbClr val="000000"/>
                 </a:solidFill>
@@ -2280,14 +2284,14 @@
           </a:ln>
           <a:extLst>
             <a:ext uri="{909E8E84-426E-40dd-AFC4-6F175D3DCCD1}">
-              <a14:hiddenFill xmlns:a14="http://schemas.microsoft.com/office/drawing/2010/main" xmlns="">
+              <a14:hiddenFill xmlns="" xmlns:a14="http://schemas.microsoft.com/office/drawing/2010/main">
                 <a:solidFill>
                   <a:srgbClr val="FFFFFF"/>
                 </a:solidFill>
               </a14:hiddenFill>
             </a:ext>
             <a:ext uri="{FAA26D3D-D897-4be2-8F04-BA451C77F1D7}">
-              <ma14:placeholderFlag xmlns:ma14="http://schemas.microsoft.com/office/mac/drawingml/2011/main" xmlns="" val="1"/>
+              <ma14:placeholderFlag xmlns="" xmlns:ma14="http://schemas.microsoft.com/office/mac/drawingml/2011/main" val="1"/>
             </a:ext>
           </a:extLst>
         </p:spPr>
@@ -2306,14 +2310,14 @@
           <a:noFill/>
           <a:extLst>
             <a:ext uri="{909E8E84-426E-40dd-AFC4-6F175D3DCCD1}">
-              <a14:hiddenFill xmlns:a14="http://schemas.microsoft.com/office/drawing/2010/main" xmlns="">
+              <a14:hiddenFill xmlns="" xmlns:a14="http://schemas.microsoft.com/office/drawing/2010/main">
                 <a:solidFill>
                   <a:srgbClr val="FFFFFF"/>
                 </a:solidFill>
               </a14:hiddenFill>
             </a:ext>
             <a:ext uri="{91240B29-F687-4f45-9708-019B960494DF}">
-              <a14:hiddenLine xmlns:a14="http://schemas.microsoft.com/office/drawing/2010/main" xmlns="" w="9525">
+              <a14:hiddenLine xmlns="" xmlns:a14="http://schemas.microsoft.com/office/drawing/2010/main" w="9525">
                 <a:solidFill>
                   <a:srgbClr val="000000"/>
                 </a:solidFill>
@@ -2467,14 +2471,14 @@
           </a:ln>
           <a:extLst>
             <a:ext uri="{909E8E84-426E-40dd-AFC4-6F175D3DCCD1}">
-              <a14:hiddenFill xmlns:a14="http://schemas.microsoft.com/office/drawing/2010/main" xmlns="">
+              <a14:hiddenFill xmlns="" xmlns:a14="http://schemas.microsoft.com/office/drawing/2010/main">
                 <a:solidFill>
                   <a:srgbClr val="FFFFFF"/>
                 </a:solidFill>
               </a14:hiddenFill>
             </a:ext>
             <a:ext uri="{FAA26D3D-D897-4be2-8F04-BA451C77F1D7}">
-              <ma14:placeholderFlag xmlns:ma14="http://schemas.microsoft.com/office/mac/drawingml/2011/main" xmlns="" val="1"/>
+              <ma14:placeholderFlag xmlns="" xmlns:ma14="http://schemas.microsoft.com/office/mac/drawingml/2011/main" val="1"/>
             </a:ext>
           </a:extLst>
         </p:spPr>
@@ -2493,14 +2497,14 @@
           <a:noFill/>
           <a:extLst>
             <a:ext uri="{909E8E84-426E-40dd-AFC4-6F175D3DCCD1}">
-              <a14:hiddenFill xmlns:a14="http://schemas.microsoft.com/office/drawing/2010/main" xmlns="">
+              <a14:hiddenFill xmlns="" xmlns:a14="http://schemas.microsoft.com/office/drawing/2010/main">
                 <a:solidFill>
                   <a:srgbClr val="FFFFFF"/>
                 </a:solidFill>
               </a14:hiddenFill>
             </a:ext>
             <a:ext uri="{91240B29-F687-4f45-9708-019B960494DF}">
-              <a14:hiddenLine xmlns:a14="http://schemas.microsoft.com/office/drawing/2010/main" xmlns="" w="9525">
+              <a14:hiddenLine xmlns="" xmlns:a14="http://schemas.microsoft.com/office/drawing/2010/main" w="9525">
                 <a:solidFill>
                   <a:srgbClr val="000000"/>
                 </a:solidFill>
@@ -2585,14 +2589,14 @@
           </a:ln>
           <a:extLst>
             <a:ext uri="{909E8E84-426E-40dd-AFC4-6F175D3DCCD1}">
-              <a14:hiddenFill xmlns:a14="http://schemas.microsoft.com/office/drawing/2010/main" xmlns="">
+              <a14:hiddenFill xmlns="" xmlns:a14="http://schemas.microsoft.com/office/drawing/2010/main">
                 <a:solidFill>
                   <a:srgbClr val="FFFFFF"/>
                 </a:solidFill>
               </a14:hiddenFill>
             </a:ext>
             <a:ext uri="{FAA26D3D-D897-4be2-8F04-BA451C77F1D7}">
-              <ma14:placeholderFlag xmlns:ma14="http://schemas.microsoft.com/office/mac/drawingml/2011/main" xmlns="" val="1"/>
+              <ma14:placeholderFlag xmlns="" xmlns:ma14="http://schemas.microsoft.com/office/mac/drawingml/2011/main" val="1"/>
             </a:ext>
           </a:extLst>
         </p:spPr>
@@ -2611,14 +2615,14 @@
           <a:noFill/>
           <a:extLst>
             <a:ext uri="{909E8E84-426E-40dd-AFC4-6F175D3DCCD1}">
-              <a14:hiddenFill xmlns:a14="http://schemas.microsoft.com/office/drawing/2010/main" xmlns="">
+              <a14:hiddenFill xmlns="" xmlns:a14="http://schemas.microsoft.com/office/drawing/2010/main">
                 <a:solidFill>
                   <a:srgbClr val="FFFFFF"/>
                 </a:solidFill>
               </a14:hiddenFill>
             </a:ext>
             <a:ext uri="{91240B29-F687-4f45-9708-019B960494DF}">
-              <a14:hiddenLine xmlns:a14="http://schemas.microsoft.com/office/drawing/2010/main" xmlns="" w="9525">
+              <a14:hiddenLine xmlns="" xmlns:a14="http://schemas.microsoft.com/office/drawing/2010/main" w="9525">
                 <a:solidFill>
                   <a:srgbClr val="000000"/>
                 </a:solidFill>
@@ -2794,14 +2798,14 @@
           </a:ln>
           <a:extLst>
             <a:ext uri="{909E8E84-426E-40dd-AFC4-6F175D3DCCD1}">
-              <a14:hiddenFill xmlns:a14="http://schemas.microsoft.com/office/drawing/2010/main" xmlns="">
+              <a14:hiddenFill xmlns="" xmlns:a14="http://schemas.microsoft.com/office/drawing/2010/main">
                 <a:solidFill>
                   <a:srgbClr val="FFFFFF"/>
                 </a:solidFill>
               </a14:hiddenFill>
             </a:ext>
             <a:ext uri="{FAA26D3D-D897-4be2-8F04-BA451C77F1D7}">
-              <ma14:placeholderFlag xmlns:ma14="http://schemas.microsoft.com/office/mac/drawingml/2011/main" xmlns="" val="1"/>
+              <ma14:placeholderFlag xmlns="" xmlns:ma14="http://schemas.microsoft.com/office/mac/drawingml/2011/main" val="1"/>
             </a:ext>
           </a:extLst>
         </p:spPr>
@@ -2820,14 +2824,14 @@
           <a:noFill/>
           <a:extLst>
             <a:ext uri="{909E8E84-426E-40dd-AFC4-6F175D3DCCD1}">
-              <a14:hiddenFill xmlns:a14="http://schemas.microsoft.com/office/drawing/2010/main" xmlns="">
+              <a14:hiddenFill xmlns="" xmlns:a14="http://schemas.microsoft.com/office/drawing/2010/main">
                 <a:solidFill>
                   <a:srgbClr val="FFFFFF"/>
                 </a:solidFill>
               </a14:hiddenFill>
             </a:ext>
             <a:ext uri="{91240B29-F687-4f45-9708-019B960494DF}">
-              <a14:hiddenLine xmlns:a14="http://schemas.microsoft.com/office/drawing/2010/main" xmlns="" w="9525">
+              <a14:hiddenLine xmlns="" xmlns:a14="http://schemas.microsoft.com/office/drawing/2010/main" w="9525">
                 <a:solidFill>
                   <a:srgbClr val="000000"/>
                 </a:solidFill>
@@ -3064,14 +3068,14 @@
           </a:ln>
           <a:extLst>
             <a:ext uri="{909E8E84-426E-40dd-AFC4-6F175D3DCCD1}">
-              <a14:hiddenFill xmlns:a14="http://schemas.microsoft.com/office/drawing/2010/main" xmlns="">
+              <a14:hiddenFill xmlns="" xmlns:a14="http://schemas.microsoft.com/office/drawing/2010/main">
                 <a:solidFill>
                   <a:srgbClr val="FFFFFF"/>
                 </a:solidFill>
               </a14:hiddenFill>
             </a:ext>
             <a:ext uri="{FAA26D3D-D897-4be2-8F04-BA451C77F1D7}">
-              <ma14:placeholderFlag xmlns:ma14="http://schemas.microsoft.com/office/mac/drawingml/2011/main" xmlns="" val="1"/>
+              <ma14:placeholderFlag xmlns="" xmlns:ma14="http://schemas.microsoft.com/office/mac/drawingml/2011/main" val="1"/>
             </a:ext>
           </a:extLst>
         </p:spPr>
@@ -3090,14 +3094,14 @@
           <a:noFill/>
           <a:extLst>
             <a:ext uri="{909E8E84-426E-40dd-AFC4-6F175D3DCCD1}">
-              <a14:hiddenFill xmlns:a14="http://schemas.microsoft.com/office/drawing/2010/main" xmlns="">
+              <a14:hiddenFill xmlns="" xmlns:a14="http://schemas.microsoft.com/office/drawing/2010/main">
                 <a:solidFill>
                   <a:srgbClr val="FFFFFF"/>
                 </a:solidFill>
               </a14:hiddenFill>
             </a:ext>
             <a:ext uri="{91240B29-F687-4f45-9708-019B960494DF}">
-              <a14:hiddenLine xmlns:a14="http://schemas.microsoft.com/office/drawing/2010/main" xmlns="" w="9525">
+              <a14:hiddenLine xmlns="" xmlns:a14="http://schemas.microsoft.com/office/drawing/2010/main" w="9525">
                 <a:solidFill>
                   <a:srgbClr val="000000"/>
                 </a:solidFill>
@@ -3448,14 +3452,14 @@
           </a:ln>
           <a:extLst>
             <a:ext uri="{909E8E84-426E-40dd-AFC4-6F175D3DCCD1}">
-              <a14:hiddenFill xmlns:a14="http://schemas.microsoft.com/office/drawing/2010/main" xmlns="">
+              <a14:hiddenFill xmlns="" xmlns:a14="http://schemas.microsoft.com/office/drawing/2010/main">
                 <a:solidFill>
                   <a:srgbClr val="FFFFFF"/>
                 </a:solidFill>
               </a14:hiddenFill>
             </a:ext>
             <a:ext uri="{91240B29-F687-4f45-9708-019B960494DF}">
-              <a14:hiddenLine xmlns:a14="http://schemas.microsoft.com/office/drawing/2010/main" xmlns="" w="9525">
+              <a14:hiddenLine xmlns="" xmlns:a14="http://schemas.microsoft.com/office/drawing/2010/main" w="9525">
                 <a:solidFill>
                   <a:srgbClr val="000000"/>
                 </a:solidFill>
@@ -4735,14 +4739,14 @@
           </a:ln>
           <a:extLst>
             <a:ext uri="{909E8E84-426E-40dd-AFC4-6F175D3DCCD1}">
-              <a14:hiddenFill xmlns:a14="http://schemas.microsoft.com/office/drawing/2010/main" xmlns="">
+              <a14:hiddenFill xmlns="" xmlns:a14="http://schemas.microsoft.com/office/drawing/2010/main">
                 <a:solidFill>
                   <a:srgbClr val="FFFFFF"/>
                 </a:solidFill>
               </a14:hiddenFill>
             </a:ext>
             <a:ext uri="{91240B29-F687-4f45-9708-019B960494DF}">
-              <a14:hiddenLine xmlns:a14="http://schemas.microsoft.com/office/drawing/2010/main" xmlns="" w="9525">
+              <a14:hiddenLine xmlns="" xmlns:a14="http://schemas.microsoft.com/office/drawing/2010/main" w="9525">
                 <a:solidFill>
                   <a:srgbClr val="000000"/>
                 </a:solidFill>
@@ -4819,14 +4823,14 @@
           </a:ln>
           <a:extLst>
             <a:ext uri="{909E8E84-426E-40dd-AFC4-6F175D3DCCD1}">
-              <a14:hiddenFill xmlns:a14="http://schemas.microsoft.com/office/drawing/2010/main" xmlns="">
+              <a14:hiddenFill xmlns="" xmlns:a14="http://schemas.microsoft.com/office/drawing/2010/main">
                 <a:solidFill>
                   <a:srgbClr val="FFFFFF"/>
                 </a:solidFill>
               </a14:hiddenFill>
             </a:ext>
             <a:ext uri="{91240B29-F687-4f45-9708-019B960494DF}">
-              <a14:hiddenLine xmlns:a14="http://schemas.microsoft.com/office/drawing/2010/main" xmlns="" w="9525">
+              <a14:hiddenLine xmlns="" xmlns:a14="http://schemas.microsoft.com/office/drawing/2010/main" w="9525">
                 <a:solidFill>
                   <a:srgbClr val="000000"/>
                 </a:solidFill>
@@ -8105,14 +8109,14 @@
           </a:ln>
           <a:extLst>
             <a:ext uri="{909E8E84-426E-40dd-AFC4-6F175D3DCCD1}">
-              <a14:hiddenFill xmlns:a14="http://schemas.microsoft.com/office/drawing/2010/main" xmlns="">
+              <a14:hiddenFill xmlns="" xmlns:a14="http://schemas.microsoft.com/office/drawing/2010/main">
                 <a:solidFill>
                   <a:srgbClr val="FFFFFF"/>
                 </a:solidFill>
               </a14:hiddenFill>
             </a:ext>
             <a:ext uri="{91240B29-F687-4f45-9708-019B960494DF}">
-              <a14:hiddenLine xmlns:a14="http://schemas.microsoft.com/office/drawing/2010/main" xmlns="" w="9525">
+              <a14:hiddenLine xmlns="" xmlns:a14="http://schemas.microsoft.com/office/drawing/2010/main" w="9525">
                 <a:solidFill>
                   <a:srgbClr val="000000"/>
                 </a:solidFill>
@@ -9186,14 +9190,14 @@
           </a:ln>
           <a:extLst>
             <a:ext uri="{909E8E84-426E-40dd-AFC4-6F175D3DCCD1}">
-              <a14:hiddenFill xmlns:a14="http://schemas.microsoft.com/office/drawing/2010/main" xmlns="">
+              <a14:hiddenFill xmlns="" xmlns:a14="http://schemas.microsoft.com/office/drawing/2010/main">
                 <a:solidFill>
                   <a:srgbClr val="FFFFFF"/>
                 </a:solidFill>
               </a14:hiddenFill>
             </a:ext>
             <a:ext uri="{91240B29-F687-4f45-9708-019B960494DF}">
-              <a14:hiddenLine xmlns:a14="http://schemas.microsoft.com/office/drawing/2010/main" xmlns="" w="9525">
+              <a14:hiddenLine xmlns="" xmlns:a14="http://schemas.microsoft.com/office/drawing/2010/main" w="9525">
                 <a:solidFill>
                   <a:srgbClr val="000000"/>
                 </a:solidFill>
@@ -9229,14 +9233,14 @@
           </a:ln>
           <a:extLst>
             <a:ext uri="{909E8E84-426E-40dd-AFC4-6F175D3DCCD1}">
-              <a14:hiddenFill xmlns:a14="http://schemas.microsoft.com/office/drawing/2010/main" xmlns="">
+              <a14:hiddenFill xmlns="" xmlns:a14="http://schemas.microsoft.com/office/drawing/2010/main">
                 <a:solidFill>
                   <a:srgbClr val="FFFFFF"/>
                 </a:solidFill>
               </a14:hiddenFill>
             </a:ext>
             <a:ext uri="{91240B29-F687-4f45-9708-019B960494DF}">
-              <a14:hiddenLine xmlns:a14="http://schemas.microsoft.com/office/drawing/2010/main" xmlns="" w="9525">
+              <a14:hiddenLine xmlns="" xmlns:a14="http://schemas.microsoft.com/office/drawing/2010/main" w="9525">
                 <a:solidFill>
                   <a:srgbClr val="000000"/>
                 </a:solidFill>
@@ -9246,7 +9250,7 @@
               </a14:hiddenLine>
             </a:ext>
             <a:ext uri="{FAA26D3D-D897-4be2-8F04-BA451C77F1D7}">
-              <ma14:placeholderFlag xmlns:ma14="http://schemas.microsoft.com/office/mac/drawingml/2011/main" xmlns="" val="1"/>
+              <ma14:placeholderFlag xmlns="" xmlns:ma14="http://schemas.microsoft.com/office/mac/drawingml/2011/main" val="1"/>
             </a:ext>
           </a:extLst>
         </p:spPr>
@@ -9792,14 +9796,14 @@
           </a:ln>
           <a:extLst>
             <a:ext uri="{909E8E84-426E-40dd-AFC4-6F175D3DCCD1}">
-              <a14:hiddenFill xmlns:a14="http://schemas.microsoft.com/office/drawing/2010/main" xmlns="">
+              <a14:hiddenFill xmlns="" xmlns:a14="http://schemas.microsoft.com/office/drawing/2010/main">
                 <a:solidFill>
                   <a:srgbClr val="FFFFFF"/>
                 </a:solidFill>
               </a14:hiddenFill>
             </a:ext>
             <a:ext uri="{91240B29-F687-4f45-9708-019B960494DF}">
-              <a14:hiddenLine xmlns:a14="http://schemas.microsoft.com/office/drawing/2010/main" xmlns="" w="9525">
+              <a14:hiddenLine xmlns="" xmlns:a14="http://schemas.microsoft.com/office/drawing/2010/main" w="9525">
                 <a:solidFill>
                   <a:srgbClr val="000000"/>
                 </a:solidFill>
@@ -9835,14 +9839,14 @@
           </a:ln>
           <a:extLst>
             <a:ext uri="{909E8E84-426E-40dd-AFC4-6F175D3DCCD1}">
-              <a14:hiddenFill xmlns:a14="http://schemas.microsoft.com/office/drawing/2010/main" xmlns="">
+              <a14:hiddenFill xmlns="" xmlns:a14="http://schemas.microsoft.com/office/drawing/2010/main">
                 <a:solidFill>
                   <a:srgbClr val="FFFFFF"/>
                 </a:solidFill>
               </a14:hiddenFill>
             </a:ext>
             <a:ext uri="{91240B29-F687-4f45-9708-019B960494DF}">
-              <a14:hiddenLine xmlns:a14="http://schemas.microsoft.com/office/drawing/2010/main" xmlns="" w="9525">
+              <a14:hiddenLine xmlns="" xmlns:a14="http://schemas.microsoft.com/office/drawing/2010/main" w="9525">
                 <a:solidFill>
                   <a:srgbClr val="000000"/>
                 </a:solidFill>
@@ -9852,7 +9856,7 @@
               </a14:hiddenLine>
             </a:ext>
             <a:ext uri="{FAA26D3D-D897-4be2-8F04-BA451C77F1D7}">
-              <ma14:placeholderFlag xmlns:ma14="http://schemas.microsoft.com/office/mac/drawingml/2011/main" xmlns="" val="1"/>
+              <ma14:placeholderFlag xmlns="" xmlns:ma14="http://schemas.microsoft.com/office/mac/drawingml/2011/main" val="1"/>
             </a:ext>
           </a:extLst>
         </p:spPr>
@@ -10494,6 +10498,606 @@
       </p:grpSpPr>
       <p:sp>
         <p:nvSpPr>
+          <p:cNvPr id="2" name="Text Placeholder 1"/>
+          <p:cNvSpPr>
+            <a:spLocks noGrp="1"/>
+          </p:cNvSpPr>
+          <p:nvPr>
+            <p:ph type="body" sz="quarter" idx="11"/>
+          </p:nvPr>
+        </p:nvSpPr>
+        <p:spPr>
+          <a:xfrm>
+            <a:off x="705985" y="1891756"/>
+            <a:ext cx="13245156" cy="553998"/>
+          </a:xfrm>
+        </p:spPr>
+        <p:txBody>
+          <a:bodyPr/>
+          <a:lstStyle/>
+          <a:p>
+            <a:r>
+              <a:rPr lang="en-US" dirty="0">
+                <a:solidFill>
+                  <a:srgbClr val="4C4C4C"/>
+                </a:solidFill>
+                <a:latin typeface="BentonSans Book" charset="0"/>
+              </a:rPr>
+              <a:t>Data Interpreter</a:t>
+            </a:r>
+            <a:endParaRPr lang="en-US" dirty="0"/>
+          </a:p>
+        </p:txBody>
+      </p:sp>
+    </p:spTree>
+    <p:custDataLst>
+      <p:tags r:id="rId1"/>
+    </p:custDataLst>
+  </p:cSld>
+  <p:clrMapOvr>
+    <a:masterClrMapping/>
+  </p:clrMapOvr>
+</p:sld>
+</file>
+
+<file path=ppt/slides/slide11.xml><?xml version="1.0" encoding="utf-8"?>
+<p:sld xmlns:a="http://schemas.openxmlformats.org/drawingml/2006/main" xmlns:r="http://schemas.openxmlformats.org/officeDocument/2006/relationships" xmlns:p="http://schemas.openxmlformats.org/presentationml/2006/main">
+  <p:cSld>
+    <p:spTree>
+      <p:nvGrpSpPr>
+        <p:cNvPr id="1" name=""/>
+        <p:cNvGrpSpPr/>
+        <p:nvPr/>
+      </p:nvGrpSpPr>
+      <p:grpSpPr>
+        <a:xfrm>
+          <a:off x="0" y="0"/>
+          <a:ext cx="0" cy="0"/>
+          <a:chOff x="0" y="0"/>
+          <a:chExt cx="0" cy="0"/>
+        </a:xfrm>
+      </p:grpSpPr>
+      <p:sp>
+        <p:nvSpPr>
+          <p:cNvPr id="2" name="Content Placeholder 1"/>
+          <p:cNvSpPr>
+            <a:spLocks noGrp="1"/>
+          </p:cNvSpPr>
+          <p:nvPr>
+            <p:ph idx="14"/>
+          </p:nvPr>
+        </p:nvSpPr>
+        <p:spPr>
+          <a:xfrm>
+            <a:off x="537027" y="1893515"/>
+            <a:ext cx="4049488" cy="2893100"/>
+          </a:xfrm>
+        </p:spPr>
+        <p:txBody>
+          <a:bodyPr/>
+          <a:lstStyle/>
+          <a:p>
+            <a:pPr lvl="0"/>
+            <a:r>
+              <a:rPr lang="en-US"/>
+              <a:t>Open Tableau Desktop</a:t>
+            </a:r>
+          </a:p>
+          <a:p>
+            <a:pPr lvl="0"/>
+            <a:r>
+              <a:rPr lang="en-US"/>
+              <a:t>Click on Excel</a:t>
+            </a:r>
+          </a:p>
+          <a:p>
+            <a:pPr lvl="0"/>
+            <a:r>
+              <a:rPr lang="en-US"/>
+              <a:t>Navigate to saved file</a:t>
+            </a:r>
+          </a:p>
+          <a:p>
+            <a:pPr lvl="0"/>
+            <a:r>
+              <a:rPr lang="en-US"/>
+              <a:t>Click open</a:t>
+            </a:r>
+          </a:p>
+          <a:p>
+            <a:r>
+              <a:rPr lang="en-US"/>
+              <a:t>Drag “Resolved Incidents” to the canvas</a:t>
+            </a:r>
+            <a:endParaRPr lang="en-US" dirty="0">
+              <a:ea typeface="+mn-ea"/>
+            </a:endParaRPr>
+          </a:p>
+        </p:txBody>
+      </p:sp>
+      <p:sp>
+        <p:nvSpPr>
+          <p:cNvPr id="3" name="Text Placeholder 2"/>
+          <p:cNvSpPr>
+            <a:spLocks noGrp="1"/>
+          </p:cNvSpPr>
+          <p:nvPr>
+            <p:ph type="body" sz="quarter" idx="12"/>
+          </p:nvPr>
+        </p:nvSpPr>
+        <p:spPr>
+          <a:xfrm>
+            <a:off x="710057" y="598699"/>
+            <a:ext cx="13269093" cy="567848"/>
+          </a:xfrm>
+          <a:prstGeom prst="rect">
+            <a:avLst/>
+          </a:prstGeom>
+        </p:spPr>
+        <p:txBody>
+          <a:bodyPr/>
+          <a:lstStyle/>
+          <a:p>
+            <a:pPr defTabSz="1306221" fontAlgn="auto">
+              <a:spcAft>
+                <a:spcPts val="0"/>
+              </a:spcAft>
+              <a:defRPr/>
+            </a:pPr>
+            <a:r>
+              <a:rPr lang="en-US" dirty="0">
+                <a:ea typeface="+mn-ea"/>
+              </a:rPr>
+              <a:t>Data Interpreter</a:t>
+            </a:r>
+          </a:p>
+        </p:txBody>
+      </p:sp>
+      <p:pic>
+        <p:nvPicPr>
+          <p:cNvPr id="5" name="Picture 4" descr="A screenshot of a computer&#10;&#10;Description automatically generated">
+            <a:extLst>
+              <a:ext uri="{FF2B5EF4-FFF2-40B4-BE49-F238E27FC236}">
+                <a16:creationId xmlns:a16="http://schemas.microsoft.com/office/drawing/2014/main" id="{DC27CDD5-F960-4210-88D9-1EC45D3E6B4E}"/>
+              </a:ext>
+            </a:extLst>
+          </p:cNvPr>
+          <p:cNvPicPr>
+            <a:picLocks noChangeAspect="1"/>
+          </p:cNvPicPr>
+          <p:nvPr/>
+        </p:nvPicPr>
+        <p:blipFill rotWithShape="1">
+          <a:blip r:embed="rId4">
+            <a:extLst>
+              <a:ext uri="{28A0092B-C50C-407E-A947-70E740481C1C}">
+                <a14:useLocalDpi xmlns:a14="http://schemas.microsoft.com/office/drawing/2010/main" val="0"/>
+              </a:ext>
+            </a:extLst>
+          </a:blip>
+          <a:srcRect r="31977"/>
+          <a:stretch/>
+        </p:blipFill>
+        <p:spPr>
+          <a:xfrm>
+            <a:off x="6194630" y="1152697"/>
+            <a:ext cx="7992550" cy="5915760"/>
+          </a:xfrm>
+          <a:prstGeom prst="rect">
+            <a:avLst/>
+          </a:prstGeom>
+          <a:effectLst>
+            <a:outerShdw blurRad="63500" sx="102000" sy="102000" algn="ctr" rotWithShape="0">
+              <a:prstClr val="black">
+                <a:alpha val="40000"/>
+              </a:prstClr>
+            </a:outerShdw>
+          </a:effectLst>
+        </p:spPr>
+      </p:pic>
+    </p:spTree>
+    <p:custDataLst>
+      <p:tags r:id="rId1"/>
+    </p:custDataLst>
+    <p:extLst>
+      <p:ext uri="{BB962C8B-B14F-4D97-AF65-F5344CB8AC3E}">
+        <p14:creationId xmlns:p14="http://schemas.microsoft.com/office/powerpoint/2010/main" val="1822746233"/>
+      </p:ext>
+    </p:extLst>
+  </p:cSld>
+  <p:clrMapOvr>
+    <a:masterClrMapping/>
+  </p:clrMapOvr>
+</p:sld>
+</file>
+
+<file path=ppt/slides/slide12.xml><?xml version="1.0" encoding="utf-8"?>
+<p:sld xmlns:a="http://schemas.openxmlformats.org/drawingml/2006/main" xmlns:r="http://schemas.openxmlformats.org/officeDocument/2006/relationships" xmlns:p="http://schemas.openxmlformats.org/presentationml/2006/main">
+  <p:cSld>
+    <p:spTree>
+      <p:nvGrpSpPr>
+        <p:cNvPr id="1" name=""/>
+        <p:cNvGrpSpPr/>
+        <p:nvPr/>
+      </p:nvGrpSpPr>
+      <p:grpSpPr>
+        <a:xfrm>
+          <a:off x="0" y="0"/>
+          <a:ext cx="0" cy="0"/>
+          <a:chOff x="0" y="0"/>
+          <a:chExt cx="0" cy="0"/>
+        </a:xfrm>
+      </p:grpSpPr>
+      <p:sp>
+        <p:nvSpPr>
+          <p:cNvPr id="2" name="Content Placeholder 1"/>
+          <p:cNvSpPr>
+            <a:spLocks noGrp="1"/>
+          </p:cNvSpPr>
+          <p:nvPr>
+            <p:ph idx="14"/>
+          </p:nvPr>
+        </p:nvSpPr>
+        <p:spPr>
+          <a:xfrm>
+            <a:off x="537027" y="1893515"/>
+            <a:ext cx="4049488" cy="2893100"/>
+          </a:xfrm>
+        </p:spPr>
+        <p:txBody>
+          <a:bodyPr/>
+          <a:lstStyle/>
+          <a:p>
+            <a:pPr lvl="0"/>
+            <a:r>
+              <a:rPr lang="en-US" dirty="0"/>
+              <a:t>Open Tableau Desktop</a:t>
+            </a:r>
+          </a:p>
+          <a:p>
+            <a:pPr lvl="0"/>
+            <a:r>
+              <a:rPr lang="en-US" dirty="0"/>
+              <a:t>Click on Excel</a:t>
+            </a:r>
+          </a:p>
+          <a:p>
+            <a:pPr lvl="0"/>
+            <a:r>
+              <a:rPr lang="en-US" dirty="0"/>
+              <a:t>Navigate to saved file</a:t>
+            </a:r>
+          </a:p>
+          <a:p>
+            <a:pPr lvl="0"/>
+            <a:r>
+              <a:rPr lang="en-US" dirty="0"/>
+              <a:t>Click open</a:t>
+            </a:r>
+          </a:p>
+          <a:p>
+            <a:r>
+              <a:rPr lang="en-US" dirty="0"/>
+              <a:t>Drag “Resolved Incidents” to the canvas</a:t>
+            </a:r>
+            <a:endParaRPr lang="en-US" dirty="0">
+              <a:ea typeface="+mn-ea"/>
+            </a:endParaRPr>
+          </a:p>
+        </p:txBody>
+      </p:sp>
+      <p:sp>
+        <p:nvSpPr>
+          <p:cNvPr id="3" name="Text Placeholder 2"/>
+          <p:cNvSpPr>
+            <a:spLocks noGrp="1"/>
+          </p:cNvSpPr>
+          <p:nvPr>
+            <p:ph type="body" sz="quarter" idx="12"/>
+          </p:nvPr>
+        </p:nvSpPr>
+        <p:spPr>
+          <a:xfrm>
+            <a:off x="710057" y="598699"/>
+            <a:ext cx="13269093" cy="567848"/>
+          </a:xfrm>
+          <a:prstGeom prst="rect">
+            <a:avLst/>
+          </a:prstGeom>
+        </p:spPr>
+        <p:txBody>
+          <a:bodyPr/>
+          <a:lstStyle/>
+          <a:p>
+            <a:pPr defTabSz="1306221" fontAlgn="auto">
+              <a:spcAft>
+                <a:spcPts val="0"/>
+              </a:spcAft>
+              <a:defRPr/>
+            </a:pPr>
+            <a:r>
+              <a:rPr lang="en-US" dirty="0">
+                <a:ea typeface="+mn-ea"/>
+              </a:rPr>
+              <a:t>Data Interpreter</a:t>
+            </a:r>
+          </a:p>
+        </p:txBody>
+      </p:sp>
+      <p:pic>
+        <p:nvPicPr>
+          <p:cNvPr id="5" name="Picture 4" descr="A screenshot of a computer&#10;&#10;Description automatically generated">
+            <a:extLst>
+              <a:ext uri="{FF2B5EF4-FFF2-40B4-BE49-F238E27FC236}">
+                <a16:creationId xmlns:a16="http://schemas.microsoft.com/office/drawing/2014/main" id="{DC27CDD5-F960-4210-88D9-1EC45D3E6B4E}"/>
+              </a:ext>
+            </a:extLst>
+          </p:cNvPr>
+          <p:cNvPicPr>
+            <a:picLocks noChangeAspect="1"/>
+          </p:cNvPicPr>
+          <p:nvPr/>
+        </p:nvPicPr>
+        <p:blipFill rotWithShape="1">
+          <a:blip r:embed="rId4">
+            <a:extLst>
+              <a:ext uri="{28A0092B-C50C-407E-A947-70E740481C1C}">
+                <a14:useLocalDpi xmlns:a14="http://schemas.microsoft.com/office/drawing/2010/main" val="0"/>
+              </a:ext>
+            </a:extLst>
+          </a:blip>
+          <a:srcRect r="31977"/>
+          <a:stretch/>
+        </p:blipFill>
+        <p:spPr>
+          <a:xfrm>
+            <a:off x="6194630" y="1152697"/>
+            <a:ext cx="7992550" cy="5915760"/>
+          </a:xfrm>
+          <a:prstGeom prst="rect">
+            <a:avLst/>
+          </a:prstGeom>
+          <a:effectLst>
+            <a:outerShdw blurRad="63500" sx="102000" sy="102000" algn="ctr" rotWithShape="0">
+              <a:prstClr val="black">
+                <a:alpha val="40000"/>
+              </a:prstClr>
+            </a:outerShdw>
+          </a:effectLst>
+        </p:spPr>
+      </p:pic>
+      <p:sp>
+        <p:nvSpPr>
+          <p:cNvPr id="6" name="Arrow: Right 5">
+            <a:extLst>
+              <a:ext uri="{FF2B5EF4-FFF2-40B4-BE49-F238E27FC236}">
+                <a16:creationId xmlns:a16="http://schemas.microsoft.com/office/drawing/2014/main" id="{D99026CA-A77D-47BD-8EA5-191C4A2185AA}"/>
+              </a:ext>
+            </a:extLst>
+          </p:cNvPr>
+          <p:cNvSpPr/>
+          <p:nvPr/>
+        </p:nvSpPr>
+        <p:spPr>
+          <a:xfrm>
+            <a:off x="5595402" y="3436547"/>
+            <a:ext cx="754743" cy="380712"/>
+          </a:xfrm>
+          <a:prstGeom prst="rightArrow">
+            <a:avLst/>
+          </a:prstGeom>
+          <a:solidFill>
+            <a:srgbClr val="FF9900"/>
+          </a:solidFill>
+          <a:ln>
+            <a:noFill/>
+          </a:ln>
+        </p:spPr>
+        <p:style>
+          <a:lnRef idx="2">
+            <a:schemeClr val="accent1">
+              <a:shade val="50000"/>
+            </a:schemeClr>
+          </a:lnRef>
+          <a:fillRef idx="1">
+            <a:schemeClr val="accent1"/>
+          </a:fillRef>
+          <a:effectRef idx="0">
+            <a:schemeClr val="accent1"/>
+          </a:effectRef>
+          <a:fontRef idx="minor">
+            <a:schemeClr val="lt1"/>
+          </a:fontRef>
+        </p:style>
+        <p:txBody>
+          <a:bodyPr rtlCol="0" anchor="ctr"/>
+          <a:lstStyle/>
+          <a:p>
+            <a:pPr algn="ctr"/>
+            <a:endParaRPr lang="en-US">
+              <a:solidFill>
+                <a:srgbClr val="FF9900"/>
+              </a:solidFill>
+            </a:endParaRPr>
+          </a:p>
+        </p:txBody>
+      </p:sp>
+    </p:spTree>
+    <p:custDataLst>
+      <p:tags r:id="rId1"/>
+    </p:custDataLst>
+    <p:extLst>
+      <p:ext uri="{BB962C8B-B14F-4D97-AF65-F5344CB8AC3E}">
+        <p14:creationId xmlns:p14="http://schemas.microsoft.com/office/powerpoint/2010/main" val="452896310"/>
+      </p:ext>
+    </p:extLst>
+  </p:cSld>
+  <p:clrMapOvr>
+    <a:masterClrMapping/>
+  </p:clrMapOvr>
+</p:sld>
+</file>
+
+<file path=ppt/slides/slide13.xml><?xml version="1.0" encoding="utf-8"?>
+<p:sld xmlns:a="http://schemas.openxmlformats.org/drawingml/2006/main" xmlns:r="http://schemas.openxmlformats.org/officeDocument/2006/relationships" xmlns:p="http://schemas.openxmlformats.org/presentationml/2006/main">
+  <p:cSld>
+    <p:spTree>
+      <p:nvGrpSpPr>
+        <p:cNvPr id="1" name=""/>
+        <p:cNvGrpSpPr/>
+        <p:nvPr/>
+      </p:nvGrpSpPr>
+      <p:grpSpPr>
+        <a:xfrm>
+          <a:off x="0" y="0"/>
+          <a:ext cx="0" cy="0"/>
+          <a:chOff x="0" y="0"/>
+          <a:chExt cx="0" cy="0"/>
+        </a:xfrm>
+      </p:grpSpPr>
+      <p:sp>
+        <p:nvSpPr>
+          <p:cNvPr id="2" name="Content Placeholder 1"/>
+          <p:cNvSpPr>
+            <a:spLocks noGrp="1"/>
+          </p:cNvSpPr>
+          <p:nvPr>
+            <p:ph idx="14"/>
+          </p:nvPr>
+        </p:nvSpPr>
+        <p:spPr>
+          <a:xfrm>
+            <a:off x="710057" y="1059545"/>
+            <a:ext cx="13273820" cy="430887"/>
+          </a:xfrm>
+        </p:spPr>
+        <p:txBody>
+          <a:bodyPr/>
+          <a:lstStyle/>
+          <a:p>
+            <a:pPr lvl="0"/>
+            <a:r>
+              <a:rPr lang="en-US" dirty="0"/>
+              <a:t>Click the Run Interpreter Box</a:t>
+            </a:r>
+          </a:p>
+        </p:txBody>
+      </p:sp>
+      <p:sp>
+        <p:nvSpPr>
+          <p:cNvPr id="3" name="Text Placeholder 2"/>
+          <p:cNvSpPr>
+            <a:spLocks noGrp="1"/>
+          </p:cNvSpPr>
+          <p:nvPr>
+            <p:ph type="body" sz="quarter" idx="12"/>
+          </p:nvPr>
+        </p:nvSpPr>
+        <p:spPr>
+          <a:xfrm>
+            <a:off x="714784" y="248048"/>
+            <a:ext cx="13269093" cy="553998"/>
+          </a:xfrm>
+          <a:prstGeom prst="rect">
+            <a:avLst/>
+          </a:prstGeom>
+        </p:spPr>
+        <p:txBody>
+          <a:bodyPr/>
+          <a:lstStyle/>
+          <a:p>
+            <a:pPr defTabSz="1306221" fontAlgn="auto">
+              <a:spcAft>
+                <a:spcPts val="0"/>
+              </a:spcAft>
+              <a:defRPr/>
+            </a:pPr>
+            <a:r>
+              <a:rPr lang="en-US" dirty="0">
+                <a:ea typeface="+mn-ea"/>
+              </a:rPr>
+              <a:t>Data Interpreter</a:t>
+            </a:r>
+          </a:p>
+        </p:txBody>
+      </p:sp>
+      <p:pic>
+        <p:nvPicPr>
+          <p:cNvPr id="5" name="Picture 4" descr="A screenshot of a social media post&#10;&#10;Description automatically generated">
+            <a:extLst>
+              <a:ext uri="{FF2B5EF4-FFF2-40B4-BE49-F238E27FC236}">
+                <a16:creationId xmlns:a16="http://schemas.microsoft.com/office/drawing/2014/main" id="{AEB0F8B9-7D29-4CC4-BE57-0B052E9D132A}"/>
+              </a:ext>
+            </a:extLst>
+          </p:cNvPr>
+          <p:cNvPicPr>
+            <a:picLocks noChangeAspect="1"/>
+          </p:cNvPicPr>
+          <p:nvPr/>
+        </p:nvPicPr>
+        <p:blipFill rotWithShape="1">
+          <a:blip r:embed="rId4">
+            <a:extLst>
+              <a:ext uri="{28A0092B-C50C-407E-A947-70E740481C1C}">
+                <a14:useLocalDpi xmlns:a14="http://schemas.microsoft.com/office/drawing/2010/main" val="0"/>
+              </a:ext>
+            </a:extLst>
+          </a:blip>
+          <a:srcRect t="1437" r="305" b="3806"/>
+          <a:stretch/>
+        </p:blipFill>
+        <p:spPr>
+          <a:xfrm>
+            <a:off x="1855676" y="1756227"/>
+            <a:ext cx="10919048" cy="5225143"/>
+          </a:xfrm>
+          <a:prstGeom prst="rect">
+            <a:avLst/>
+          </a:prstGeom>
+          <a:effectLst>
+            <a:outerShdw blurRad="63500" sx="102000" sy="102000" algn="ctr" rotWithShape="0">
+              <a:prstClr val="black">
+                <a:alpha val="40000"/>
+              </a:prstClr>
+            </a:outerShdw>
+          </a:effectLst>
+        </p:spPr>
+      </p:pic>
+    </p:spTree>
+    <p:custDataLst>
+      <p:tags r:id="rId1"/>
+    </p:custDataLst>
+    <p:extLst>
+      <p:ext uri="{BB962C8B-B14F-4D97-AF65-F5344CB8AC3E}">
+        <p14:creationId xmlns:p14="http://schemas.microsoft.com/office/powerpoint/2010/main" val="2423286755"/>
+      </p:ext>
+    </p:extLst>
+  </p:cSld>
+  <p:clrMapOvr>
+    <a:masterClrMapping/>
+  </p:clrMapOvr>
+</p:sld>
+</file>
+
+<file path=ppt/slides/slide14.xml><?xml version="1.0" encoding="utf-8"?>
+<p:sld xmlns:a="http://schemas.openxmlformats.org/drawingml/2006/main" xmlns:r="http://schemas.openxmlformats.org/officeDocument/2006/relationships" xmlns:p="http://schemas.openxmlformats.org/presentationml/2006/main">
+  <p:cSld>
+    <p:spTree>
+      <p:nvGrpSpPr>
+        <p:cNvPr id="1" name=""/>
+        <p:cNvGrpSpPr/>
+        <p:nvPr/>
+      </p:nvGrpSpPr>
+      <p:grpSpPr>
+        <a:xfrm>
+          <a:off x="0" y="0"/>
+          <a:ext cx="0" cy="0"/>
+          <a:chOff x="0" y="0"/>
+          <a:chExt cx="0" cy="0"/>
+        </a:xfrm>
+      </p:grpSpPr>
+      <p:sp>
+        <p:nvSpPr>
           <p:cNvPr id="3" name="Text Placeholder 2"/>
           <p:cNvSpPr>
             <a:spLocks noGrp="1"/>
@@ -10644,7 +11248,7 @@
 </p:sld>
 </file>
 
-<file path=ppt/slides/slide11.xml><?xml version="1.0" encoding="utf-8"?>
+<file path=ppt/slides/slide15.xml><?xml version="1.0" encoding="utf-8"?>
 <p:sld xmlns:a="http://schemas.openxmlformats.org/drawingml/2006/main" xmlns:r="http://schemas.openxmlformats.org/officeDocument/2006/relationships" xmlns:p="http://schemas.openxmlformats.org/presentationml/2006/main">
   <p:cSld>
     <p:spTree>
@@ -10757,7 +11361,7 @@
 </p:sld>
 </file>
 
-<file path=ppt/slides/slide12.xml><?xml version="1.0" encoding="utf-8"?>
+<file path=ppt/slides/slide16.xml><?xml version="1.0" encoding="utf-8"?>
 <p:sld xmlns:a="http://schemas.openxmlformats.org/drawingml/2006/main" xmlns:r="http://schemas.openxmlformats.org/officeDocument/2006/relationships" xmlns:p="http://schemas.openxmlformats.org/presentationml/2006/main">
   <p:cSld>
     <p:spTree>
@@ -10870,7 +11474,7 @@
 </p:sld>
 </file>
 
-<file path=ppt/slides/slide13.xml><?xml version="1.0" encoding="utf-8"?>
+<file path=ppt/slides/slide17.xml><?xml version="1.0" encoding="utf-8"?>
 <p:sld xmlns:a="http://schemas.openxmlformats.org/drawingml/2006/main" xmlns:r="http://schemas.openxmlformats.org/officeDocument/2006/relationships" xmlns:p="http://schemas.openxmlformats.org/presentationml/2006/main">
   <p:cSld>
     <p:spTree>
@@ -10933,7 +11537,7 @@
 </p:sld>
 </file>
 
-<file path=ppt/slides/slide14.xml><?xml version="1.0" encoding="utf-8"?>
+<file path=ppt/slides/slide18.xml><?xml version="1.0" encoding="utf-8"?>
 <p:sld xmlns:a="http://schemas.openxmlformats.org/drawingml/2006/main" xmlns:r="http://schemas.openxmlformats.org/officeDocument/2006/relationships" xmlns:p="http://schemas.openxmlformats.org/presentationml/2006/main">
   <p:cSld>
     <p:spTree>
@@ -11047,7 +11651,7 @@
 </p:sld>
 </file>
 
-<file path=ppt/slides/slide15.xml><?xml version="1.0" encoding="utf-8"?>
+<file path=ppt/slides/slide19.xml><?xml version="1.0" encoding="utf-8"?>
 <p:sld xmlns:a="http://schemas.openxmlformats.org/drawingml/2006/main" xmlns:r="http://schemas.openxmlformats.org/officeDocument/2006/relationships" xmlns:p="http://schemas.openxmlformats.org/presentationml/2006/main">
   <p:cSld>
     <p:spTree>
@@ -11257,7 +11861,170 @@
 </p:sld>
 </file>
 
-<file path=ppt/slides/slide16.xml><?xml version="1.0" encoding="utf-8"?>
+<file path=ppt/slides/slide2.xml><?xml version="1.0" encoding="utf-8"?>
+<p:sld xmlns:a="http://schemas.openxmlformats.org/drawingml/2006/main" xmlns:r="http://schemas.openxmlformats.org/officeDocument/2006/relationships" xmlns:p="http://schemas.openxmlformats.org/presentationml/2006/main">
+  <p:cSld>
+    <p:spTree>
+      <p:nvGrpSpPr>
+        <p:cNvPr id="1" name=""/>
+        <p:cNvGrpSpPr/>
+        <p:nvPr/>
+      </p:nvGrpSpPr>
+      <p:grpSpPr>
+        <a:xfrm>
+          <a:off x="0" y="0"/>
+          <a:ext cx="0" cy="0"/>
+          <a:chOff x="0" y="0"/>
+          <a:chExt cx="0" cy="0"/>
+        </a:xfrm>
+      </p:grpSpPr>
+      <p:sp>
+        <p:nvSpPr>
+          <p:cNvPr id="6" name="Content Placeholder 5">
+            <a:extLst>
+              <a:ext uri="{FF2B5EF4-FFF2-40B4-BE49-F238E27FC236}">
+                <a16:creationId xmlns:a16="http://schemas.microsoft.com/office/drawing/2014/main" id="{CDF0501C-A6A2-4C6E-9840-A0187A9A170F}"/>
+              </a:ext>
+            </a:extLst>
+          </p:cNvPr>
+          <p:cNvSpPr>
+            <a:spLocks noGrp="1"/>
+          </p:cNvSpPr>
+          <p:nvPr>
+            <p:ph idx="14"/>
+          </p:nvPr>
+        </p:nvSpPr>
+        <p:spPr>
+          <a:xfrm>
+            <a:off x="704476" y="1893515"/>
+            <a:ext cx="13273820" cy="3570208"/>
+          </a:xfrm>
+        </p:spPr>
+        <p:txBody>
+          <a:bodyPr/>
+          <a:lstStyle/>
+          <a:p>
+            <a:r>
+              <a:rPr lang="en-US" dirty="0"/>
+              <a:t>(E)</a:t>
+            </a:r>
+            <a:r>
+              <a:rPr lang="en-US" dirty="0" err="1"/>
+              <a:t>xtract</a:t>
+            </a:r>
+            <a:r>
+              <a:rPr lang="en-US" dirty="0"/>
+              <a:t>, (T)</a:t>
+            </a:r>
+            <a:r>
+              <a:rPr lang="en-US" dirty="0" err="1"/>
+              <a:t>ransform</a:t>
+            </a:r>
+            <a:r>
+              <a:rPr lang="en-US" dirty="0"/>
+              <a:t>, (L)</a:t>
+            </a:r>
+            <a:r>
+              <a:rPr lang="en-US" dirty="0" err="1"/>
+              <a:t>oad</a:t>
+            </a:r>
+            <a:r>
+              <a:rPr lang="en-US" dirty="0"/>
+              <a:t> Process</a:t>
+            </a:r>
+          </a:p>
+          <a:p>
+            <a:pPr lvl="1"/>
+            <a:r>
+              <a:rPr lang="en-US" dirty="0"/>
+              <a:t>A 3 step process to get data into a place where it can be analyzed (w/ Tableau in our case).</a:t>
+            </a:r>
+          </a:p>
+          <a:p>
+            <a:r>
+              <a:rPr lang="en-US" dirty="0"/>
+              <a:t>It can be organized with four stages</a:t>
+            </a:r>
+          </a:p>
+          <a:p>
+            <a:pPr lvl="1"/>
+            <a:r>
+              <a:rPr lang="en-US" dirty="0"/>
+              <a:t>1. Data Extraction</a:t>
+            </a:r>
+          </a:p>
+          <a:p>
+            <a:pPr lvl="2"/>
+            <a:r>
+              <a:rPr lang="en-US" dirty="0"/>
+              <a:t>Pulling data from it’s original source (raw data).</a:t>
+            </a:r>
+          </a:p>
+          <a:p>
+            <a:pPr lvl="1"/>
+            <a:r>
+              <a:rPr lang="en-US" dirty="0"/>
+              <a:t>2. Data Cleansing</a:t>
+            </a:r>
+          </a:p>
+          <a:p>
+            <a:pPr lvl="1"/>
+            <a:r>
+              <a:rPr lang="en-US" dirty="0"/>
+              <a:t>3. Transformation</a:t>
+            </a:r>
+          </a:p>
+          <a:p>
+            <a:pPr lvl="1"/>
+            <a:r>
+              <a:rPr lang="en-US" dirty="0"/>
+              <a:t>4. Load</a:t>
+            </a:r>
+          </a:p>
+        </p:txBody>
+      </p:sp>
+      <p:sp>
+        <p:nvSpPr>
+          <p:cNvPr id="5" name="Text Placeholder 4">
+            <a:extLst>
+              <a:ext uri="{FF2B5EF4-FFF2-40B4-BE49-F238E27FC236}">
+                <a16:creationId xmlns:a16="http://schemas.microsoft.com/office/drawing/2014/main" id="{9CACBD77-645C-4DC2-A181-97943EF1FC8A}"/>
+              </a:ext>
+            </a:extLst>
+          </p:cNvPr>
+          <p:cNvSpPr>
+            <a:spLocks noGrp="1"/>
+          </p:cNvSpPr>
+          <p:nvPr>
+            <p:ph type="body" sz="quarter" idx="12"/>
+          </p:nvPr>
+        </p:nvSpPr>
+        <p:spPr/>
+        <p:txBody>
+          <a:bodyPr/>
+          <a:lstStyle/>
+          <a:p>
+            <a:r>
+              <a:rPr lang="en-US" dirty="0"/>
+              <a:t>ETL Process</a:t>
+            </a:r>
+          </a:p>
+        </p:txBody>
+      </p:sp>
+    </p:spTree>
+    <p:extLst>
+      <p:ext uri="{BB962C8B-B14F-4D97-AF65-F5344CB8AC3E}">
+        <p14:creationId xmlns:p14="http://schemas.microsoft.com/office/powerpoint/2010/main" val="2459760168"/>
+      </p:ext>
+    </p:extLst>
+  </p:cSld>
+  <p:clrMapOvr>
+    <a:masterClrMapping/>
+  </p:clrMapOvr>
+</p:sld>
+</file>
+
+<file path=ppt/slides/slide20.xml><?xml version="1.0" encoding="utf-8"?>
 <p:sld xmlns:a="http://schemas.openxmlformats.org/drawingml/2006/main" xmlns:r="http://schemas.openxmlformats.org/officeDocument/2006/relationships" xmlns:p="http://schemas.openxmlformats.org/presentationml/2006/main">
   <p:cSld>
     <p:spTree>
@@ -11453,7 +12220,7 @@
 </p:sld>
 </file>
 
-<file path=ppt/slides/slide17.xml><?xml version="1.0" encoding="utf-8"?>
+<file path=ppt/slides/slide21.xml><?xml version="1.0" encoding="utf-8"?>
 <p:sld xmlns:a="http://schemas.openxmlformats.org/drawingml/2006/main" xmlns:r="http://schemas.openxmlformats.org/officeDocument/2006/relationships" xmlns:p="http://schemas.openxmlformats.org/presentationml/2006/main">
   <p:cSld>
     <p:spTree>
@@ -11637,7 +12404,7 @@
 </p:sld>
 </file>
 
-<file path=ppt/slides/slide18.xml><?xml version="1.0" encoding="utf-8"?>
+<file path=ppt/slides/slide22.xml><?xml version="1.0" encoding="utf-8"?>
 <p:sld xmlns:a="http://schemas.openxmlformats.org/drawingml/2006/main" xmlns:r="http://schemas.openxmlformats.org/officeDocument/2006/relationships" xmlns:p="http://schemas.openxmlformats.org/presentationml/2006/main">
   <p:cSld>
     <p:spTree>
@@ -11703,7 +12470,7 @@
 </p:sld>
 </file>
 
-<file path=ppt/slides/slide19.xml><?xml version="1.0" encoding="utf-8"?>
+<file path=ppt/slides/slide23.xml><?xml version="1.0" encoding="utf-8"?>
 <p:sld xmlns:a="http://schemas.openxmlformats.org/drawingml/2006/main" xmlns:r="http://schemas.openxmlformats.org/officeDocument/2006/relationships" xmlns:p="http://schemas.openxmlformats.org/presentationml/2006/main">
   <p:cSld>
     <p:spTree>
@@ -11899,73 +12666,7 @@
 </p:sld>
 </file>
 
-<file path=ppt/slides/slide2.xml><?xml version="1.0" encoding="utf-8"?>
-<p:sld xmlns:a="http://schemas.openxmlformats.org/drawingml/2006/main" xmlns:r="http://schemas.openxmlformats.org/officeDocument/2006/relationships" xmlns:p="http://schemas.openxmlformats.org/presentationml/2006/main">
-  <p:cSld>
-    <p:spTree>
-      <p:nvGrpSpPr>
-        <p:cNvPr id="1" name=""/>
-        <p:cNvGrpSpPr/>
-        <p:nvPr/>
-      </p:nvGrpSpPr>
-      <p:grpSpPr>
-        <a:xfrm>
-          <a:off x="0" y="0"/>
-          <a:ext cx="0" cy="0"/>
-          <a:chOff x="0" y="0"/>
-          <a:chExt cx="0" cy="0"/>
-        </a:xfrm>
-      </p:grpSpPr>
-      <p:sp>
-        <p:nvSpPr>
-          <p:cNvPr id="2" name="Text Placeholder 1"/>
-          <p:cNvSpPr>
-            <a:spLocks noGrp="1"/>
-          </p:cNvSpPr>
-          <p:nvPr>
-            <p:ph type="body" sz="quarter" idx="11"/>
-          </p:nvPr>
-        </p:nvSpPr>
-        <p:spPr>
-          <a:xfrm>
-            <a:off x="705985" y="1891756"/>
-            <a:ext cx="13245156" cy="553998"/>
-          </a:xfrm>
-        </p:spPr>
-        <p:txBody>
-          <a:bodyPr/>
-          <a:lstStyle/>
-          <a:p>
-            <a:r>
-              <a:rPr lang="en-US" dirty="0">
-                <a:solidFill>
-                  <a:srgbClr val="4C4C4C"/>
-                </a:solidFill>
-                <a:latin typeface="BentonSans Book" charset="0"/>
-              </a:rPr>
-              <a:t>Poorly Formatted Data</a:t>
-            </a:r>
-            <a:endParaRPr lang="en-US" dirty="0"/>
-          </a:p>
-        </p:txBody>
-      </p:sp>
-    </p:spTree>
-    <p:custDataLst>
-      <p:tags r:id="rId1"/>
-    </p:custDataLst>
-    <p:extLst>
-      <p:ext uri="{BB962C8B-B14F-4D97-AF65-F5344CB8AC3E}">
-        <p14:creationId xmlns:p14="http://schemas.microsoft.com/office/powerpoint/2010/main" val="2385230617"/>
-      </p:ext>
-    </p:extLst>
-  </p:cSld>
-  <p:clrMapOvr>
-    <a:masterClrMapping/>
-  </p:clrMapOvr>
-</p:sld>
-</file>
-
-<file path=ppt/slides/slide20.xml><?xml version="1.0" encoding="utf-8"?>
+<file path=ppt/slides/slide24.xml><?xml version="1.0" encoding="utf-8"?>
 <p:sld xmlns:a="http://schemas.openxmlformats.org/drawingml/2006/main" xmlns:r="http://schemas.openxmlformats.org/officeDocument/2006/relationships" xmlns:p="http://schemas.openxmlformats.org/presentationml/2006/main">
   <p:cSld>
     <p:spTree>
@@ -12112,7 +12813,7 @@
 </p:sld>
 </file>
 
-<file path=ppt/slides/slide21.xml><?xml version="1.0" encoding="utf-8"?>
+<file path=ppt/slides/slide25.xml><?xml version="1.0" encoding="utf-8"?>
 <p:sld xmlns:a="http://schemas.openxmlformats.org/drawingml/2006/main" xmlns:r="http://schemas.openxmlformats.org/officeDocument/2006/relationships" xmlns:p="http://schemas.openxmlformats.org/presentationml/2006/main">
   <p:cSld>
     <p:spTree>
@@ -12296,7 +12997,7 @@
 </p:sld>
 </file>
 
-<file path=ppt/slides/slide22.xml><?xml version="1.0" encoding="utf-8"?>
+<file path=ppt/slides/slide26.xml><?xml version="1.0" encoding="utf-8"?>
 <p:sld xmlns:a="http://schemas.openxmlformats.org/drawingml/2006/main" xmlns:r="http://schemas.openxmlformats.org/officeDocument/2006/relationships" xmlns:p="http://schemas.openxmlformats.org/presentationml/2006/main">
   <p:cSld>
     <p:spTree>
@@ -12343,6 +13044,481 @@
       </p:grpSpPr>
       <p:sp>
         <p:nvSpPr>
+          <p:cNvPr id="2" name="Content Placeholder 1">
+            <a:extLst>
+              <a:ext uri="{FF2B5EF4-FFF2-40B4-BE49-F238E27FC236}">
+                <a16:creationId xmlns:a16="http://schemas.microsoft.com/office/drawing/2014/main" id="{39843DF9-4EA9-4B34-BE2B-3D846CE8E532}"/>
+              </a:ext>
+            </a:extLst>
+          </p:cNvPr>
+          <p:cNvSpPr>
+            <a:spLocks noGrp="1"/>
+          </p:cNvSpPr>
+          <p:nvPr>
+            <p:ph idx="14"/>
+          </p:nvPr>
+        </p:nvSpPr>
+        <p:spPr>
+          <a:xfrm>
+            <a:off x="704476" y="1893515"/>
+            <a:ext cx="13273820" cy="4185761"/>
+          </a:xfrm>
+        </p:spPr>
+        <p:txBody>
+          <a:bodyPr/>
+          <a:lstStyle/>
+          <a:p>
+            <a:r>
+              <a:rPr lang="en-US" dirty="0"/>
+              <a:t>As mentioned, data comes form many different sources</a:t>
+            </a:r>
+          </a:p>
+          <a:p>
+            <a:r>
+              <a:rPr lang="en-US" dirty="0"/>
+              <a:t>Most common mediums are:</a:t>
+            </a:r>
+          </a:p>
+          <a:p>
+            <a:pPr lvl="1"/>
+            <a:r>
+              <a:rPr lang="en-US" dirty="0"/>
+              <a:t>Databases</a:t>
+            </a:r>
+          </a:p>
+          <a:p>
+            <a:pPr lvl="1"/>
+            <a:r>
+              <a:rPr lang="en-US" dirty="0"/>
+              <a:t>Flat files</a:t>
+            </a:r>
+          </a:p>
+          <a:p>
+            <a:pPr lvl="1"/>
+            <a:r>
+              <a:rPr lang="en-US" dirty="0"/>
+              <a:t>Web Services</a:t>
+            </a:r>
+          </a:p>
+          <a:p>
+            <a:pPr lvl="1"/>
+            <a:r>
+              <a:rPr lang="en-US" dirty="0"/>
+              <a:t>etc.</a:t>
+            </a:r>
+          </a:p>
+          <a:p>
+            <a:pPr lvl="1"/>
+            <a:endParaRPr lang="en-US" dirty="0"/>
+          </a:p>
+          <a:p>
+            <a:r>
+              <a:rPr lang="en-US" dirty="0"/>
+              <a:t>Global Superstore </a:t>
+            </a:r>
+          </a:p>
+          <a:p>
+            <a:pPr lvl="1"/>
+            <a:r>
+              <a:rPr lang="en-US" dirty="0"/>
+              <a:t>Excel File, Access DB, Flat File (csv)</a:t>
+            </a:r>
+          </a:p>
+        </p:txBody>
+      </p:sp>
+      <p:sp>
+        <p:nvSpPr>
+          <p:cNvPr id="3" name="Text Placeholder 2">
+            <a:extLst>
+              <a:ext uri="{FF2B5EF4-FFF2-40B4-BE49-F238E27FC236}">
+                <a16:creationId xmlns:a16="http://schemas.microsoft.com/office/drawing/2014/main" id="{CAC0CADE-48AA-4ACD-8F67-553971D1226B}"/>
+              </a:ext>
+            </a:extLst>
+          </p:cNvPr>
+          <p:cNvSpPr>
+            <a:spLocks noGrp="1"/>
+          </p:cNvSpPr>
+          <p:nvPr>
+            <p:ph type="body" sz="quarter" idx="12"/>
+          </p:nvPr>
+        </p:nvSpPr>
+        <p:spPr/>
+        <p:txBody>
+          <a:bodyPr/>
+          <a:lstStyle/>
+          <a:p>
+            <a:r>
+              <a:rPr lang="en-US" dirty="0"/>
+              <a:t>Step 1 - Extraction</a:t>
+            </a:r>
+          </a:p>
+        </p:txBody>
+      </p:sp>
+    </p:spTree>
+    <p:extLst>
+      <p:ext uri="{BB962C8B-B14F-4D97-AF65-F5344CB8AC3E}">
+        <p14:creationId xmlns:p14="http://schemas.microsoft.com/office/powerpoint/2010/main" val="3733609617"/>
+      </p:ext>
+    </p:extLst>
+  </p:cSld>
+  <p:clrMapOvr>
+    <a:masterClrMapping/>
+  </p:clrMapOvr>
+</p:sld>
+</file>
+
+<file path=ppt/slides/slide4.xml><?xml version="1.0" encoding="utf-8"?>
+<p:sld xmlns:a="http://schemas.openxmlformats.org/drawingml/2006/main" xmlns:r="http://schemas.openxmlformats.org/officeDocument/2006/relationships" xmlns:p="http://schemas.openxmlformats.org/presentationml/2006/main">
+  <p:cSld>
+    <p:spTree>
+      <p:nvGrpSpPr>
+        <p:cNvPr id="1" name=""/>
+        <p:cNvGrpSpPr/>
+        <p:nvPr/>
+      </p:nvGrpSpPr>
+      <p:grpSpPr>
+        <a:xfrm>
+          <a:off x="0" y="0"/>
+          <a:ext cx="0" cy="0"/>
+          <a:chOff x="0" y="0"/>
+          <a:chExt cx="0" cy="0"/>
+        </a:xfrm>
+      </p:grpSpPr>
+      <p:sp>
+        <p:nvSpPr>
+          <p:cNvPr id="2" name="Content Placeholder 1">
+            <a:extLst>
+              <a:ext uri="{FF2B5EF4-FFF2-40B4-BE49-F238E27FC236}">
+                <a16:creationId xmlns:a16="http://schemas.microsoft.com/office/drawing/2014/main" id="{258CA44A-AD30-408E-99AE-2E5A0013C38D}"/>
+              </a:ext>
+            </a:extLst>
+          </p:cNvPr>
+          <p:cNvSpPr>
+            <a:spLocks noGrp="1"/>
+          </p:cNvSpPr>
+          <p:nvPr>
+            <p:ph idx="14"/>
+          </p:nvPr>
+        </p:nvSpPr>
+        <p:spPr>
+          <a:xfrm>
+            <a:off x="704476" y="1893515"/>
+            <a:ext cx="13273820" cy="5909310"/>
+          </a:xfrm>
+        </p:spPr>
+        <p:txBody>
+          <a:bodyPr/>
+          <a:lstStyle/>
+          <a:p>
+            <a:r>
+              <a:rPr lang="en-US" dirty="0"/>
+              <a:t>Cleaning of the data can fall under the transformation step</a:t>
+            </a:r>
+          </a:p>
+          <a:p>
+            <a:r>
+              <a:rPr lang="en-US" dirty="0"/>
+              <a:t>Potential Problems to Solve with Data Cleansing</a:t>
+            </a:r>
+          </a:p>
+          <a:p>
+            <a:pPr lvl="1"/>
+            <a:r>
+              <a:rPr lang="en-US" dirty="0"/>
+              <a:t>Uniqueness</a:t>
+            </a:r>
+          </a:p>
+          <a:p>
+            <a:pPr lvl="1"/>
+            <a:r>
+              <a:rPr lang="en-US" dirty="0"/>
+              <a:t>Misspelling</a:t>
+            </a:r>
+          </a:p>
+          <a:p>
+            <a:pPr lvl="1"/>
+            <a:r>
+              <a:rPr lang="en-US" dirty="0"/>
+              <a:t>Duplicates</a:t>
+            </a:r>
+          </a:p>
+          <a:p>
+            <a:pPr lvl="1"/>
+            <a:r>
+              <a:rPr lang="en-US" dirty="0"/>
+              <a:t>Outside Domain Range</a:t>
+            </a:r>
+          </a:p>
+          <a:p>
+            <a:pPr lvl="1"/>
+            <a:r>
+              <a:rPr lang="en-US" dirty="0"/>
+              <a:t>Data Entry Errors</a:t>
+            </a:r>
+          </a:p>
+          <a:p>
+            <a:pPr lvl="1"/>
+            <a:r>
+              <a:rPr lang="en-US" dirty="0"/>
+              <a:t>Naming Conflicts</a:t>
+            </a:r>
+          </a:p>
+          <a:p>
+            <a:pPr lvl="1"/>
+            <a:endParaRPr lang="en-US" dirty="0"/>
+          </a:p>
+          <a:p>
+            <a:r>
+              <a:rPr lang="en-US" dirty="0"/>
+              <a:t>Transformation</a:t>
+            </a:r>
+          </a:p>
+          <a:p>
+            <a:pPr lvl="1"/>
+            <a:r>
+              <a:rPr lang="en-US" dirty="0"/>
+              <a:t>Format Standardization</a:t>
+            </a:r>
+          </a:p>
+          <a:p>
+            <a:pPr lvl="1"/>
+            <a:r>
+              <a:rPr lang="en-US" dirty="0"/>
+              <a:t>Removing Duplicates</a:t>
+            </a:r>
+          </a:p>
+          <a:p>
+            <a:pPr lvl="1"/>
+            <a:endParaRPr lang="en-US" dirty="0"/>
+          </a:p>
+        </p:txBody>
+      </p:sp>
+      <p:sp>
+        <p:nvSpPr>
+          <p:cNvPr id="3" name="Text Placeholder 2">
+            <a:extLst>
+              <a:ext uri="{FF2B5EF4-FFF2-40B4-BE49-F238E27FC236}">
+                <a16:creationId xmlns:a16="http://schemas.microsoft.com/office/drawing/2014/main" id="{15795037-355E-40CC-8E66-54EBF75D38EE}"/>
+              </a:ext>
+            </a:extLst>
+          </p:cNvPr>
+          <p:cNvSpPr>
+            <a:spLocks noGrp="1"/>
+          </p:cNvSpPr>
+          <p:nvPr>
+            <p:ph type="body" sz="quarter" idx="12"/>
+          </p:nvPr>
+        </p:nvSpPr>
+        <p:spPr/>
+        <p:txBody>
+          <a:bodyPr/>
+          <a:lstStyle/>
+          <a:p>
+            <a:r>
+              <a:rPr lang="en-US" dirty="0"/>
+              <a:t>Steps 2&amp;3 – Data Cleansing/Transformation </a:t>
+            </a:r>
+          </a:p>
+        </p:txBody>
+      </p:sp>
+    </p:spTree>
+    <p:extLst>
+      <p:ext uri="{BB962C8B-B14F-4D97-AF65-F5344CB8AC3E}">
+        <p14:creationId xmlns:p14="http://schemas.microsoft.com/office/powerpoint/2010/main" val="3976684355"/>
+      </p:ext>
+    </p:extLst>
+  </p:cSld>
+  <p:clrMapOvr>
+    <a:masterClrMapping/>
+  </p:clrMapOvr>
+</p:sld>
+</file>
+
+<file path=ppt/slides/slide5.xml><?xml version="1.0" encoding="utf-8"?>
+<p:sld xmlns:a="http://schemas.openxmlformats.org/drawingml/2006/main" xmlns:r="http://schemas.openxmlformats.org/officeDocument/2006/relationships" xmlns:p="http://schemas.openxmlformats.org/presentationml/2006/main">
+  <p:cSld>
+    <p:spTree>
+      <p:nvGrpSpPr>
+        <p:cNvPr id="1" name=""/>
+        <p:cNvGrpSpPr/>
+        <p:nvPr/>
+      </p:nvGrpSpPr>
+      <p:grpSpPr>
+        <a:xfrm>
+          <a:off x="0" y="0"/>
+          <a:ext cx="0" cy="0"/>
+          <a:chOff x="0" y="0"/>
+          <a:chExt cx="0" cy="0"/>
+        </a:xfrm>
+      </p:grpSpPr>
+      <p:sp>
+        <p:nvSpPr>
+          <p:cNvPr id="2" name="Content Placeholder 1">
+            <a:extLst>
+              <a:ext uri="{FF2B5EF4-FFF2-40B4-BE49-F238E27FC236}">
+                <a16:creationId xmlns:a16="http://schemas.microsoft.com/office/drawing/2014/main" id="{08C07CEC-AE63-4ACA-9CFF-6E9F2D061C1A}"/>
+              </a:ext>
+            </a:extLst>
+          </p:cNvPr>
+          <p:cNvSpPr>
+            <a:spLocks noGrp="1"/>
+          </p:cNvSpPr>
+          <p:nvPr>
+            <p:ph idx="14"/>
+          </p:nvPr>
+        </p:nvSpPr>
+        <p:spPr>
+          <a:xfrm>
+            <a:off x="704476" y="1893515"/>
+            <a:ext cx="13273820" cy="1877437"/>
+          </a:xfrm>
+        </p:spPr>
+        <p:txBody>
+          <a:bodyPr/>
+          <a:lstStyle/>
+          <a:p>
+            <a:r>
+              <a:rPr lang="en-US" dirty="0"/>
+              <a:t>Loading into an application or storing in a Data Warehouse/Flat File</a:t>
+            </a:r>
+          </a:p>
+          <a:p>
+            <a:endParaRPr lang="en-US" dirty="0"/>
+          </a:p>
+          <a:p>
+            <a:r>
+              <a:rPr lang="en-US" dirty="0"/>
+              <a:t>If we were strictly data analysis at a company, we would hopefully get the data generated from the last step to load into our program (Tableau)</a:t>
+            </a:r>
+          </a:p>
+        </p:txBody>
+      </p:sp>
+      <p:sp>
+        <p:nvSpPr>
+          <p:cNvPr id="3" name="Text Placeholder 2">
+            <a:extLst>
+              <a:ext uri="{FF2B5EF4-FFF2-40B4-BE49-F238E27FC236}">
+                <a16:creationId xmlns:a16="http://schemas.microsoft.com/office/drawing/2014/main" id="{CF4D769A-806E-444D-8C3C-5B41F00D8754}"/>
+              </a:ext>
+            </a:extLst>
+          </p:cNvPr>
+          <p:cNvSpPr>
+            <a:spLocks noGrp="1"/>
+          </p:cNvSpPr>
+          <p:nvPr>
+            <p:ph type="body" sz="quarter" idx="12"/>
+          </p:nvPr>
+        </p:nvSpPr>
+        <p:spPr/>
+        <p:txBody>
+          <a:bodyPr/>
+          <a:lstStyle/>
+          <a:p>
+            <a:r>
+              <a:rPr lang="en-US" dirty="0"/>
+              <a:t>Step 4 – Data Loading</a:t>
+            </a:r>
+          </a:p>
+        </p:txBody>
+      </p:sp>
+    </p:spTree>
+    <p:extLst>
+      <p:ext uri="{BB962C8B-B14F-4D97-AF65-F5344CB8AC3E}">
+        <p14:creationId xmlns:p14="http://schemas.microsoft.com/office/powerpoint/2010/main" val="3838415463"/>
+      </p:ext>
+    </p:extLst>
+  </p:cSld>
+  <p:clrMapOvr>
+    <a:masterClrMapping/>
+  </p:clrMapOvr>
+</p:sld>
+</file>
+
+<file path=ppt/slides/slide6.xml><?xml version="1.0" encoding="utf-8"?>
+<p:sld xmlns:a="http://schemas.openxmlformats.org/drawingml/2006/main" xmlns:r="http://schemas.openxmlformats.org/officeDocument/2006/relationships" xmlns:p="http://schemas.openxmlformats.org/presentationml/2006/main">
+  <p:cSld>
+    <p:spTree>
+      <p:nvGrpSpPr>
+        <p:cNvPr id="1" name=""/>
+        <p:cNvGrpSpPr/>
+        <p:nvPr/>
+      </p:nvGrpSpPr>
+      <p:grpSpPr>
+        <a:xfrm>
+          <a:off x="0" y="0"/>
+          <a:ext cx="0" cy="0"/>
+          <a:chOff x="0" y="0"/>
+          <a:chExt cx="0" cy="0"/>
+        </a:xfrm>
+      </p:grpSpPr>
+      <p:sp>
+        <p:nvSpPr>
+          <p:cNvPr id="2" name="Text Placeholder 1"/>
+          <p:cNvSpPr>
+            <a:spLocks noGrp="1"/>
+          </p:cNvSpPr>
+          <p:nvPr>
+            <p:ph type="body" sz="quarter" idx="11"/>
+          </p:nvPr>
+        </p:nvSpPr>
+        <p:spPr>
+          <a:xfrm>
+            <a:off x="705985" y="1891756"/>
+            <a:ext cx="13245156" cy="553998"/>
+          </a:xfrm>
+        </p:spPr>
+        <p:txBody>
+          <a:bodyPr/>
+          <a:lstStyle/>
+          <a:p>
+            <a:r>
+              <a:rPr lang="en-US" dirty="0">
+                <a:solidFill>
+                  <a:srgbClr val="4C4C4C"/>
+                </a:solidFill>
+                <a:latin typeface="BentonSans Book" charset="0"/>
+              </a:rPr>
+              <a:t>Poorly Formatted Data</a:t>
+            </a:r>
+            <a:endParaRPr lang="en-US" dirty="0"/>
+          </a:p>
+        </p:txBody>
+      </p:sp>
+    </p:spTree>
+    <p:custDataLst>
+      <p:tags r:id="rId1"/>
+    </p:custDataLst>
+    <p:extLst>
+      <p:ext uri="{BB962C8B-B14F-4D97-AF65-F5344CB8AC3E}">
+        <p14:creationId xmlns:p14="http://schemas.microsoft.com/office/powerpoint/2010/main" val="2385230617"/>
+      </p:ext>
+    </p:extLst>
+  </p:cSld>
+  <p:clrMapOvr>
+    <a:masterClrMapping/>
+  </p:clrMapOvr>
+</p:sld>
+</file>
+
+<file path=ppt/slides/slide7.xml><?xml version="1.0" encoding="utf-8"?>
+<p:sld xmlns:a="http://schemas.openxmlformats.org/drawingml/2006/main" xmlns:r="http://schemas.openxmlformats.org/officeDocument/2006/relationships" xmlns:p="http://schemas.openxmlformats.org/presentationml/2006/main">
+  <p:cSld>
+    <p:spTree>
+      <p:nvGrpSpPr>
+        <p:cNvPr id="1" name=""/>
+        <p:cNvGrpSpPr/>
+        <p:nvPr/>
+      </p:nvGrpSpPr>
+      <p:grpSpPr>
+        <a:xfrm>
+          <a:off x="0" y="0"/>
+          <a:ext cx="0" cy="0"/>
+          <a:chOff x="0" y="0"/>
+          <a:chExt cx="0" cy="0"/>
+        </a:xfrm>
+      </p:grpSpPr>
+      <p:sp>
+        <p:nvSpPr>
           <p:cNvPr id="2" name="Content Placeholder 1"/>
           <p:cNvSpPr>
             <a:spLocks noGrp="1"/>
@@ -12464,7 +13640,7 @@
 </p:sld>
 </file>
 
-<file path=ppt/slides/slide4.xml><?xml version="1.0" encoding="utf-8"?>
+<file path=ppt/slides/slide8.xml><?xml version="1.0" encoding="utf-8"?>
 <p:sld xmlns:a="http://schemas.openxmlformats.org/drawingml/2006/main" xmlns:r="http://schemas.openxmlformats.org/officeDocument/2006/relationships" xmlns:p="http://schemas.openxmlformats.org/presentationml/2006/main">
   <p:cSld>
     <p:spTree>
@@ -12627,7 +13803,7 @@
 </p:sld>
 </file>
 
-<file path=ppt/slides/slide5.xml><?xml version="1.0" encoding="utf-8"?>
+<file path=ppt/slides/slide9.xml><?xml version="1.0" encoding="utf-8"?>
 <p:sld xmlns:a="http://schemas.openxmlformats.org/drawingml/2006/main" xmlns:r="http://schemas.openxmlformats.org/officeDocument/2006/relationships" xmlns:p="http://schemas.openxmlformats.org/presentationml/2006/main">
   <p:cSld>
     <p:spTree>
@@ -12758,606 +13934,6 @@
     <p:extLst>
       <p:ext uri="{BB962C8B-B14F-4D97-AF65-F5344CB8AC3E}">
         <p14:creationId xmlns:p14="http://schemas.microsoft.com/office/powerpoint/2010/main" val="1885648857"/>
-      </p:ext>
-    </p:extLst>
-  </p:cSld>
-  <p:clrMapOvr>
-    <a:masterClrMapping/>
-  </p:clrMapOvr>
-</p:sld>
-</file>
-
-<file path=ppt/slides/slide6.xml><?xml version="1.0" encoding="utf-8"?>
-<p:sld xmlns:a="http://schemas.openxmlformats.org/drawingml/2006/main" xmlns:r="http://schemas.openxmlformats.org/officeDocument/2006/relationships" xmlns:p="http://schemas.openxmlformats.org/presentationml/2006/main">
-  <p:cSld>
-    <p:spTree>
-      <p:nvGrpSpPr>
-        <p:cNvPr id="1" name=""/>
-        <p:cNvGrpSpPr/>
-        <p:nvPr/>
-      </p:nvGrpSpPr>
-      <p:grpSpPr>
-        <a:xfrm>
-          <a:off x="0" y="0"/>
-          <a:ext cx="0" cy="0"/>
-          <a:chOff x="0" y="0"/>
-          <a:chExt cx="0" cy="0"/>
-        </a:xfrm>
-      </p:grpSpPr>
-      <p:sp>
-        <p:nvSpPr>
-          <p:cNvPr id="2" name="Text Placeholder 1"/>
-          <p:cNvSpPr>
-            <a:spLocks noGrp="1"/>
-          </p:cNvSpPr>
-          <p:nvPr>
-            <p:ph type="body" sz="quarter" idx="11"/>
-          </p:nvPr>
-        </p:nvSpPr>
-        <p:spPr>
-          <a:xfrm>
-            <a:off x="705985" y="1891756"/>
-            <a:ext cx="13245156" cy="553998"/>
-          </a:xfrm>
-        </p:spPr>
-        <p:txBody>
-          <a:bodyPr/>
-          <a:lstStyle/>
-          <a:p>
-            <a:r>
-              <a:rPr lang="en-US" dirty="0">
-                <a:solidFill>
-                  <a:srgbClr val="4C4C4C"/>
-                </a:solidFill>
-                <a:latin typeface="BentonSans Book" charset="0"/>
-              </a:rPr>
-              <a:t>Data Interpreter</a:t>
-            </a:r>
-            <a:endParaRPr lang="en-US" dirty="0"/>
-          </a:p>
-        </p:txBody>
-      </p:sp>
-    </p:spTree>
-    <p:custDataLst>
-      <p:tags r:id="rId1"/>
-    </p:custDataLst>
-  </p:cSld>
-  <p:clrMapOvr>
-    <a:masterClrMapping/>
-  </p:clrMapOvr>
-</p:sld>
-</file>
-
-<file path=ppt/slides/slide7.xml><?xml version="1.0" encoding="utf-8"?>
-<p:sld xmlns:a="http://schemas.openxmlformats.org/drawingml/2006/main" xmlns:r="http://schemas.openxmlformats.org/officeDocument/2006/relationships" xmlns:p="http://schemas.openxmlformats.org/presentationml/2006/main">
-  <p:cSld>
-    <p:spTree>
-      <p:nvGrpSpPr>
-        <p:cNvPr id="1" name=""/>
-        <p:cNvGrpSpPr/>
-        <p:nvPr/>
-      </p:nvGrpSpPr>
-      <p:grpSpPr>
-        <a:xfrm>
-          <a:off x="0" y="0"/>
-          <a:ext cx="0" cy="0"/>
-          <a:chOff x="0" y="0"/>
-          <a:chExt cx="0" cy="0"/>
-        </a:xfrm>
-      </p:grpSpPr>
-      <p:sp>
-        <p:nvSpPr>
-          <p:cNvPr id="2" name="Content Placeholder 1"/>
-          <p:cNvSpPr>
-            <a:spLocks noGrp="1"/>
-          </p:cNvSpPr>
-          <p:nvPr>
-            <p:ph idx="14"/>
-          </p:nvPr>
-        </p:nvSpPr>
-        <p:spPr>
-          <a:xfrm>
-            <a:off x="537027" y="1893515"/>
-            <a:ext cx="4049488" cy="2893100"/>
-          </a:xfrm>
-        </p:spPr>
-        <p:txBody>
-          <a:bodyPr/>
-          <a:lstStyle/>
-          <a:p>
-            <a:pPr lvl="0"/>
-            <a:r>
-              <a:rPr lang="en-US"/>
-              <a:t>Open Tableau Desktop</a:t>
-            </a:r>
-          </a:p>
-          <a:p>
-            <a:pPr lvl="0"/>
-            <a:r>
-              <a:rPr lang="en-US"/>
-              <a:t>Click on Excel</a:t>
-            </a:r>
-          </a:p>
-          <a:p>
-            <a:pPr lvl="0"/>
-            <a:r>
-              <a:rPr lang="en-US"/>
-              <a:t>Navigate to saved file</a:t>
-            </a:r>
-          </a:p>
-          <a:p>
-            <a:pPr lvl="0"/>
-            <a:r>
-              <a:rPr lang="en-US"/>
-              <a:t>Click open</a:t>
-            </a:r>
-          </a:p>
-          <a:p>
-            <a:r>
-              <a:rPr lang="en-US"/>
-              <a:t>Drag “Resolved Incidents” to the canvas</a:t>
-            </a:r>
-            <a:endParaRPr lang="en-US" dirty="0">
-              <a:ea typeface="+mn-ea"/>
-            </a:endParaRPr>
-          </a:p>
-        </p:txBody>
-      </p:sp>
-      <p:sp>
-        <p:nvSpPr>
-          <p:cNvPr id="3" name="Text Placeholder 2"/>
-          <p:cNvSpPr>
-            <a:spLocks noGrp="1"/>
-          </p:cNvSpPr>
-          <p:nvPr>
-            <p:ph type="body" sz="quarter" idx="12"/>
-          </p:nvPr>
-        </p:nvSpPr>
-        <p:spPr>
-          <a:xfrm>
-            <a:off x="710057" y="598699"/>
-            <a:ext cx="13269093" cy="567848"/>
-          </a:xfrm>
-          <a:prstGeom prst="rect">
-            <a:avLst/>
-          </a:prstGeom>
-        </p:spPr>
-        <p:txBody>
-          <a:bodyPr/>
-          <a:lstStyle/>
-          <a:p>
-            <a:pPr defTabSz="1306221" fontAlgn="auto">
-              <a:spcAft>
-                <a:spcPts val="0"/>
-              </a:spcAft>
-              <a:defRPr/>
-            </a:pPr>
-            <a:r>
-              <a:rPr lang="en-US" dirty="0">
-                <a:ea typeface="+mn-ea"/>
-              </a:rPr>
-              <a:t>Data Interpreter</a:t>
-            </a:r>
-          </a:p>
-        </p:txBody>
-      </p:sp>
-      <p:pic>
-        <p:nvPicPr>
-          <p:cNvPr id="5" name="Picture 4" descr="A screenshot of a computer&#10;&#10;Description automatically generated">
-            <a:extLst>
-              <a:ext uri="{FF2B5EF4-FFF2-40B4-BE49-F238E27FC236}">
-                <a16:creationId xmlns:a16="http://schemas.microsoft.com/office/drawing/2014/main" id="{DC27CDD5-F960-4210-88D9-1EC45D3E6B4E}"/>
-              </a:ext>
-            </a:extLst>
-          </p:cNvPr>
-          <p:cNvPicPr>
-            <a:picLocks noChangeAspect="1"/>
-          </p:cNvPicPr>
-          <p:nvPr/>
-        </p:nvPicPr>
-        <p:blipFill rotWithShape="1">
-          <a:blip r:embed="rId4">
-            <a:extLst>
-              <a:ext uri="{28A0092B-C50C-407E-A947-70E740481C1C}">
-                <a14:useLocalDpi xmlns:a14="http://schemas.microsoft.com/office/drawing/2010/main" val="0"/>
-              </a:ext>
-            </a:extLst>
-          </a:blip>
-          <a:srcRect r="31977"/>
-          <a:stretch/>
-        </p:blipFill>
-        <p:spPr>
-          <a:xfrm>
-            <a:off x="6194630" y="1152697"/>
-            <a:ext cx="7992550" cy="5915760"/>
-          </a:xfrm>
-          <a:prstGeom prst="rect">
-            <a:avLst/>
-          </a:prstGeom>
-          <a:effectLst>
-            <a:outerShdw blurRad="63500" sx="102000" sy="102000" algn="ctr" rotWithShape="0">
-              <a:prstClr val="black">
-                <a:alpha val="40000"/>
-              </a:prstClr>
-            </a:outerShdw>
-          </a:effectLst>
-        </p:spPr>
-      </p:pic>
-    </p:spTree>
-    <p:custDataLst>
-      <p:tags r:id="rId1"/>
-    </p:custDataLst>
-    <p:extLst>
-      <p:ext uri="{BB962C8B-B14F-4D97-AF65-F5344CB8AC3E}">
-        <p14:creationId xmlns:p14="http://schemas.microsoft.com/office/powerpoint/2010/main" val="1822746233"/>
-      </p:ext>
-    </p:extLst>
-  </p:cSld>
-  <p:clrMapOvr>
-    <a:masterClrMapping/>
-  </p:clrMapOvr>
-</p:sld>
-</file>
-
-<file path=ppt/slides/slide8.xml><?xml version="1.0" encoding="utf-8"?>
-<p:sld xmlns:a="http://schemas.openxmlformats.org/drawingml/2006/main" xmlns:r="http://schemas.openxmlformats.org/officeDocument/2006/relationships" xmlns:p="http://schemas.openxmlformats.org/presentationml/2006/main">
-  <p:cSld>
-    <p:spTree>
-      <p:nvGrpSpPr>
-        <p:cNvPr id="1" name=""/>
-        <p:cNvGrpSpPr/>
-        <p:nvPr/>
-      </p:nvGrpSpPr>
-      <p:grpSpPr>
-        <a:xfrm>
-          <a:off x="0" y="0"/>
-          <a:ext cx="0" cy="0"/>
-          <a:chOff x="0" y="0"/>
-          <a:chExt cx="0" cy="0"/>
-        </a:xfrm>
-      </p:grpSpPr>
-      <p:sp>
-        <p:nvSpPr>
-          <p:cNvPr id="2" name="Content Placeholder 1"/>
-          <p:cNvSpPr>
-            <a:spLocks noGrp="1"/>
-          </p:cNvSpPr>
-          <p:nvPr>
-            <p:ph idx="14"/>
-          </p:nvPr>
-        </p:nvSpPr>
-        <p:spPr>
-          <a:xfrm>
-            <a:off x="537027" y="1893515"/>
-            <a:ext cx="4049488" cy="2893100"/>
-          </a:xfrm>
-        </p:spPr>
-        <p:txBody>
-          <a:bodyPr/>
-          <a:lstStyle/>
-          <a:p>
-            <a:pPr lvl="0"/>
-            <a:r>
-              <a:rPr lang="en-US" dirty="0"/>
-              <a:t>Open Tableau Desktop</a:t>
-            </a:r>
-          </a:p>
-          <a:p>
-            <a:pPr lvl="0"/>
-            <a:r>
-              <a:rPr lang="en-US" dirty="0"/>
-              <a:t>Click on Excel</a:t>
-            </a:r>
-          </a:p>
-          <a:p>
-            <a:pPr lvl="0"/>
-            <a:r>
-              <a:rPr lang="en-US" dirty="0"/>
-              <a:t>Navigate to saved file</a:t>
-            </a:r>
-          </a:p>
-          <a:p>
-            <a:pPr lvl="0"/>
-            <a:r>
-              <a:rPr lang="en-US" dirty="0"/>
-              <a:t>Click open</a:t>
-            </a:r>
-          </a:p>
-          <a:p>
-            <a:r>
-              <a:rPr lang="en-US" dirty="0"/>
-              <a:t>Drag “Resolved Incidents” to the canvas</a:t>
-            </a:r>
-            <a:endParaRPr lang="en-US" dirty="0">
-              <a:ea typeface="+mn-ea"/>
-            </a:endParaRPr>
-          </a:p>
-        </p:txBody>
-      </p:sp>
-      <p:sp>
-        <p:nvSpPr>
-          <p:cNvPr id="3" name="Text Placeholder 2"/>
-          <p:cNvSpPr>
-            <a:spLocks noGrp="1"/>
-          </p:cNvSpPr>
-          <p:nvPr>
-            <p:ph type="body" sz="quarter" idx="12"/>
-          </p:nvPr>
-        </p:nvSpPr>
-        <p:spPr>
-          <a:xfrm>
-            <a:off x="710057" y="598699"/>
-            <a:ext cx="13269093" cy="567848"/>
-          </a:xfrm>
-          <a:prstGeom prst="rect">
-            <a:avLst/>
-          </a:prstGeom>
-        </p:spPr>
-        <p:txBody>
-          <a:bodyPr/>
-          <a:lstStyle/>
-          <a:p>
-            <a:pPr defTabSz="1306221" fontAlgn="auto">
-              <a:spcAft>
-                <a:spcPts val="0"/>
-              </a:spcAft>
-              <a:defRPr/>
-            </a:pPr>
-            <a:r>
-              <a:rPr lang="en-US" dirty="0">
-                <a:ea typeface="+mn-ea"/>
-              </a:rPr>
-              <a:t>Data Interpreter</a:t>
-            </a:r>
-          </a:p>
-        </p:txBody>
-      </p:sp>
-      <p:pic>
-        <p:nvPicPr>
-          <p:cNvPr id="5" name="Picture 4" descr="A screenshot of a computer&#10;&#10;Description automatically generated">
-            <a:extLst>
-              <a:ext uri="{FF2B5EF4-FFF2-40B4-BE49-F238E27FC236}">
-                <a16:creationId xmlns:a16="http://schemas.microsoft.com/office/drawing/2014/main" id="{DC27CDD5-F960-4210-88D9-1EC45D3E6B4E}"/>
-              </a:ext>
-            </a:extLst>
-          </p:cNvPr>
-          <p:cNvPicPr>
-            <a:picLocks noChangeAspect="1"/>
-          </p:cNvPicPr>
-          <p:nvPr/>
-        </p:nvPicPr>
-        <p:blipFill rotWithShape="1">
-          <a:blip r:embed="rId4">
-            <a:extLst>
-              <a:ext uri="{28A0092B-C50C-407E-A947-70E740481C1C}">
-                <a14:useLocalDpi xmlns:a14="http://schemas.microsoft.com/office/drawing/2010/main" val="0"/>
-              </a:ext>
-            </a:extLst>
-          </a:blip>
-          <a:srcRect r="31977"/>
-          <a:stretch/>
-        </p:blipFill>
-        <p:spPr>
-          <a:xfrm>
-            <a:off x="6194630" y="1152697"/>
-            <a:ext cx="7992550" cy="5915760"/>
-          </a:xfrm>
-          <a:prstGeom prst="rect">
-            <a:avLst/>
-          </a:prstGeom>
-          <a:effectLst>
-            <a:outerShdw blurRad="63500" sx="102000" sy="102000" algn="ctr" rotWithShape="0">
-              <a:prstClr val="black">
-                <a:alpha val="40000"/>
-              </a:prstClr>
-            </a:outerShdw>
-          </a:effectLst>
-        </p:spPr>
-      </p:pic>
-      <p:sp>
-        <p:nvSpPr>
-          <p:cNvPr id="6" name="Arrow: Right 5">
-            <a:extLst>
-              <a:ext uri="{FF2B5EF4-FFF2-40B4-BE49-F238E27FC236}">
-                <a16:creationId xmlns:a16="http://schemas.microsoft.com/office/drawing/2014/main" id="{D99026CA-A77D-47BD-8EA5-191C4A2185AA}"/>
-              </a:ext>
-            </a:extLst>
-          </p:cNvPr>
-          <p:cNvSpPr/>
-          <p:nvPr/>
-        </p:nvSpPr>
-        <p:spPr>
-          <a:xfrm>
-            <a:off x="5595402" y="3436547"/>
-            <a:ext cx="754743" cy="380712"/>
-          </a:xfrm>
-          <a:prstGeom prst="rightArrow">
-            <a:avLst/>
-          </a:prstGeom>
-          <a:solidFill>
-            <a:srgbClr val="FF9900"/>
-          </a:solidFill>
-          <a:ln>
-            <a:noFill/>
-          </a:ln>
-        </p:spPr>
-        <p:style>
-          <a:lnRef idx="2">
-            <a:schemeClr val="accent1">
-              <a:shade val="50000"/>
-            </a:schemeClr>
-          </a:lnRef>
-          <a:fillRef idx="1">
-            <a:schemeClr val="accent1"/>
-          </a:fillRef>
-          <a:effectRef idx="0">
-            <a:schemeClr val="accent1"/>
-          </a:effectRef>
-          <a:fontRef idx="minor">
-            <a:schemeClr val="lt1"/>
-          </a:fontRef>
-        </p:style>
-        <p:txBody>
-          <a:bodyPr rtlCol="0" anchor="ctr"/>
-          <a:lstStyle/>
-          <a:p>
-            <a:pPr algn="ctr"/>
-            <a:endParaRPr lang="en-US">
-              <a:solidFill>
-                <a:srgbClr val="FF9900"/>
-              </a:solidFill>
-            </a:endParaRPr>
-          </a:p>
-        </p:txBody>
-      </p:sp>
-    </p:spTree>
-    <p:custDataLst>
-      <p:tags r:id="rId1"/>
-    </p:custDataLst>
-    <p:extLst>
-      <p:ext uri="{BB962C8B-B14F-4D97-AF65-F5344CB8AC3E}">
-        <p14:creationId xmlns:p14="http://schemas.microsoft.com/office/powerpoint/2010/main" val="452896310"/>
-      </p:ext>
-    </p:extLst>
-  </p:cSld>
-  <p:clrMapOvr>
-    <a:masterClrMapping/>
-  </p:clrMapOvr>
-</p:sld>
-</file>
-
-<file path=ppt/slides/slide9.xml><?xml version="1.0" encoding="utf-8"?>
-<p:sld xmlns:a="http://schemas.openxmlformats.org/drawingml/2006/main" xmlns:r="http://schemas.openxmlformats.org/officeDocument/2006/relationships" xmlns:p="http://schemas.openxmlformats.org/presentationml/2006/main">
-  <p:cSld>
-    <p:spTree>
-      <p:nvGrpSpPr>
-        <p:cNvPr id="1" name=""/>
-        <p:cNvGrpSpPr/>
-        <p:nvPr/>
-      </p:nvGrpSpPr>
-      <p:grpSpPr>
-        <a:xfrm>
-          <a:off x="0" y="0"/>
-          <a:ext cx="0" cy="0"/>
-          <a:chOff x="0" y="0"/>
-          <a:chExt cx="0" cy="0"/>
-        </a:xfrm>
-      </p:grpSpPr>
-      <p:sp>
-        <p:nvSpPr>
-          <p:cNvPr id="2" name="Content Placeholder 1"/>
-          <p:cNvSpPr>
-            <a:spLocks noGrp="1"/>
-          </p:cNvSpPr>
-          <p:nvPr>
-            <p:ph idx="14"/>
-          </p:nvPr>
-        </p:nvSpPr>
-        <p:spPr>
-          <a:xfrm>
-            <a:off x="710057" y="1059545"/>
-            <a:ext cx="13273820" cy="430887"/>
-          </a:xfrm>
-        </p:spPr>
-        <p:txBody>
-          <a:bodyPr/>
-          <a:lstStyle/>
-          <a:p>
-            <a:pPr lvl="0"/>
-            <a:r>
-              <a:rPr lang="en-US" dirty="0"/>
-              <a:t>Click the Run Interpreter Box</a:t>
-            </a:r>
-          </a:p>
-        </p:txBody>
-      </p:sp>
-      <p:sp>
-        <p:nvSpPr>
-          <p:cNvPr id="3" name="Text Placeholder 2"/>
-          <p:cNvSpPr>
-            <a:spLocks noGrp="1"/>
-          </p:cNvSpPr>
-          <p:nvPr>
-            <p:ph type="body" sz="quarter" idx="12"/>
-          </p:nvPr>
-        </p:nvSpPr>
-        <p:spPr>
-          <a:xfrm>
-            <a:off x="714784" y="248048"/>
-            <a:ext cx="13269093" cy="553998"/>
-          </a:xfrm>
-          <a:prstGeom prst="rect">
-            <a:avLst/>
-          </a:prstGeom>
-        </p:spPr>
-        <p:txBody>
-          <a:bodyPr/>
-          <a:lstStyle/>
-          <a:p>
-            <a:pPr defTabSz="1306221" fontAlgn="auto">
-              <a:spcAft>
-                <a:spcPts val="0"/>
-              </a:spcAft>
-              <a:defRPr/>
-            </a:pPr>
-            <a:r>
-              <a:rPr lang="en-US" dirty="0">
-                <a:ea typeface="+mn-ea"/>
-              </a:rPr>
-              <a:t>Data Interpreter</a:t>
-            </a:r>
-          </a:p>
-        </p:txBody>
-      </p:sp>
-      <p:pic>
-        <p:nvPicPr>
-          <p:cNvPr id="5" name="Picture 4" descr="A screenshot of a social media post&#10;&#10;Description automatically generated">
-            <a:extLst>
-              <a:ext uri="{FF2B5EF4-FFF2-40B4-BE49-F238E27FC236}">
-                <a16:creationId xmlns:a16="http://schemas.microsoft.com/office/drawing/2014/main" id="{AEB0F8B9-7D29-4CC4-BE57-0B052E9D132A}"/>
-              </a:ext>
-            </a:extLst>
-          </p:cNvPr>
-          <p:cNvPicPr>
-            <a:picLocks noChangeAspect="1"/>
-          </p:cNvPicPr>
-          <p:nvPr/>
-        </p:nvPicPr>
-        <p:blipFill rotWithShape="1">
-          <a:blip r:embed="rId4">
-            <a:extLst>
-              <a:ext uri="{28A0092B-C50C-407E-A947-70E740481C1C}">
-                <a14:useLocalDpi xmlns:a14="http://schemas.microsoft.com/office/drawing/2010/main" val="0"/>
-              </a:ext>
-            </a:extLst>
-          </a:blip>
-          <a:srcRect t="1437" r="305" b="3806"/>
-          <a:stretch/>
-        </p:blipFill>
-        <p:spPr>
-          <a:xfrm>
-            <a:off x="1855676" y="1756227"/>
-            <a:ext cx="10919048" cy="5225143"/>
-          </a:xfrm>
-          <a:prstGeom prst="rect">
-            <a:avLst/>
-          </a:prstGeom>
-          <a:effectLst>
-            <a:outerShdw blurRad="63500" sx="102000" sy="102000" algn="ctr" rotWithShape="0">
-              <a:prstClr val="black">
-                <a:alpha val="40000"/>
-              </a:prstClr>
-            </a:outerShdw>
-          </a:effectLst>
-        </p:spPr>
-      </p:pic>
-    </p:spTree>
-    <p:custDataLst>
-      <p:tags r:id="rId1"/>
-    </p:custDataLst>
-    <p:extLst>
-      <p:ext uri="{BB962C8B-B14F-4D97-AF65-F5344CB8AC3E}">
-        <p14:creationId xmlns:p14="http://schemas.microsoft.com/office/powerpoint/2010/main" val="2423286755"/>
       </p:ext>
     </p:extLst>
   </p:cSld>

</xml_diff>